<commit_message>
Fix lỗi XML PPTX khi send_to_back hình khối nền (PowerPoint repair error)
</commit_message>
<xml_diff>
--- a/KHBD_Tin_học/Lớp_1/Tuần_02/Slide_Tin_hoc_Lop_1_Bai01_Chiec_may_tinh_cua_em.pptx
+++ b/KHBD_Tin_học/Lớp_1/Tuần_02/Slide_Tin_hoc_Lop_1_Bai01_Chiec_may_tinh_cua_em.pptx
@@ -3389,6 +3389,12 @@
 <p:sld xmlns:a="http://schemas.openxmlformats.org/drawingml/2006/main" xmlns:p="http://schemas.openxmlformats.org/presentationml/2006/main" xmlns:r="http://schemas.openxmlformats.org/officeDocument/2006/relationships">
   <p:cSld>
     <p:spTree>
+      <p:nvGrpSpPr>
+        <p:cNvPr id="1" name=""/>
+        <p:cNvGrpSpPr/>
+        <p:nvPr/>
+      </p:nvGrpSpPr>
+      <p:grpSpPr/>
       <p:sp>
         <p:nvSpPr>
           <p:cNvPr id="3" name="Rectangle 2"/>
@@ -3475,12 +3481,6 @@
           </a:p>
         </p:txBody>
       </p:sp>
-      <p:nvGrpSpPr>
-        <p:cNvPr id="1" name=""/>
-        <p:cNvGrpSpPr/>
-        <p:nvPr/>
-      </p:nvGrpSpPr>
-      <p:grpSpPr/>
       <p:sp>
         <p:nvSpPr>
           <p:cNvPr id="4" name="TextBox 3"/>
@@ -3590,6 +3590,12 @@
 <p:sld xmlns:a="http://schemas.openxmlformats.org/drawingml/2006/main" xmlns:p="http://schemas.openxmlformats.org/presentationml/2006/main" xmlns:r="http://schemas.openxmlformats.org/officeDocument/2006/relationships">
   <p:cSld>
     <p:spTree>
+      <p:nvGrpSpPr>
+        <p:cNvPr id="1" name=""/>
+        <p:cNvGrpSpPr/>
+        <p:nvPr/>
+      </p:nvGrpSpPr>
+      <p:grpSpPr/>
       <p:sp>
         <p:nvSpPr>
           <p:cNvPr id="2" name="Rectangle 1"/>
@@ -3633,12 +3639,6 @@
           </a:p>
         </p:txBody>
       </p:sp>
-      <p:nvGrpSpPr>
-        <p:cNvPr id="1" name=""/>
-        <p:cNvGrpSpPr/>
-        <p:nvPr/>
-      </p:nvGrpSpPr>
-      <p:grpSpPr/>
       <p:sp>
         <p:nvSpPr>
           <p:cNvPr id="3" name="Rectangle 2"/>
@@ -3948,6 +3948,12 @@
 <p:sld xmlns:a="http://schemas.openxmlformats.org/drawingml/2006/main" xmlns:p="http://schemas.openxmlformats.org/presentationml/2006/main" xmlns:r="http://schemas.openxmlformats.org/officeDocument/2006/relationships">
   <p:cSld>
     <p:spTree>
+      <p:nvGrpSpPr>
+        <p:cNvPr id="1" name=""/>
+        <p:cNvGrpSpPr/>
+        <p:nvPr/>
+      </p:nvGrpSpPr>
+      <p:grpSpPr/>
       <p:sp>
         <p:nvSpPr>
           <p:cNvPr id="2" name="Rectangle 1"/>
@@ -3991,12 +3997,6 @@
           </a:p>
         </p:txBody>
       </p:sp>
-      <p:nvGrpSpPr>
-        <p:cNvPr id="1" name=""/>
-        <p:cNvGrpSpPr/>
-        <p:nvPr/>
-      </p:nvGrpSpPr>
-      <p:grpSpPr/>
       <p:sp>
         <p:nvSpPr>
           <p:cNvPr id="3" name="Rectangle 2"/>
@@ -4322,6 +4322,12 @@
 <p:sld xmlns:a="http://schemas.openxmlformats.org/drawingml/2006/main" xmlns:p="http://schemas.openxmlformats.org/presentationml/2006/main" xmlns:r="http://schemas.openxmlformats.org/officeDocument/2006/relationships">
   <p:cSld>
     <p:spTree>
+      <p:nvGrpSpPr>
+        <p:cNvPr id="1" name=""/>
+        <p:cNvGrpSpPr/>
+        <p:nvPr/>
+      </p:nvGrpSpPr>
+      <p:grpSpPr/>
       <p:sp>
         <p:nvSpPr>
           <p:cNvPr id="2" name="Rectangle 1"/>
@@ -4365,12 +4371,6 @@
           </a:p>
         </p:txBody>
       </p:sp>
-      <p:nvGrpSpPr>
-        <p:cNvPr id="1" name=""/>
-        <p:cNvGrpSpPr/>
-        <p:nvPr/>
-      </p:nvGrpSpPr>
-      <p:grpSpPr/>
       <p:sp>
         <p:nvSpPr>
           <p:cNvPr id="3" name="Rectangle 2"/>
@@ -4696,6 +4696,12 @@
 <p:sld xmlns:a="http://schemas.openxmlformats.org/drawingml/2006/main" xmlns:p="http://schemas.openxmlformats.org/presentationml/2006/main" xmlns:r="http://schemas.openxmlformats.org/officeDocument/2006/relationships">
   <p:cSld>
     <p:spTree>
+      <p:nvGrpSpPr>
+        <p:cNvPr id="1" name=""/>
+        <p:cNvGrpSpPr/>
+        <p:nvPr/>
+      </p:nvGrpSpPr>
+      <p:grpSpPr/>
       <p:sp>
         <p:nvSpPr>
           <p:cNvPr id="2" name="Rectangle 1"/>
@@ -4739,12 +4745,6 @@
           </a:p>
         </p:txBody>
       </p:sp>
-      <p:nvGrpSpPr>
-        <p:cNvPr id="1" name=""/>
-        <p:cNvGrpSpPr/>
-        <p:nvPr/>
-      </p:nvGrpSpPr>
-      <p:grpSpPr/>
       <p:sp>
         <p:nvSpPr>
           <p:cNvPr id="3" name="Rectangle 2"/>
@@ -5086,6 +5086,12 @@
 <p:sld xmlns:a="http://schemas.openxmlformats.org/drawingml/2006/main" xmlns:p="http://schemas.openxmlformats.org/presentationml/2006/main" xmlns:r="http://schemas.openxmlformats.org/officeDocument/2006/relationships">
   <p:cSld>
     <p:spTree>
+      <p:nvGrpSpPr>
+        <p:cNvPr id="1" name=""/>
+        <p:cNvGrpSpPr/>
+        <p:nvPr/>
+      </p:nvGrpSpPr>
+      <p:grpSpPr/>
       <p:sp>
         <p:nvSpPr>
           <p:cNvPr id="2" name="Rectangle 1"/>
@@ -5129,12 +5135,6 @@
           </a:p>
         </p:txBody>
       </p:sp>
-      <p:nvGrpSpPr>
-        <p:cNvPr id="1" name=""/>
-        <p:cNvGrpSpPr/>
-        <p:nvPr/>
-      </p:nvGrpSpPr>
-      <p:grpSpPr/>
       <p:sp>
         <p:nvSpPr>
           <p:cNvPr id="3" name="Rectangle 2"/>
@@ -5334,6 +5334,12 @@
 <p:sld xmlns:a="http://schemas.openxmlformats.org/drawingml/2006/main" xmlns:p="http://schemas.openxmlformats.org/presentationml/2006/main" xmlns:r="http://schemas.openxmlformats.org/officeDocument/2006/relationships">
   <p:cSld>
     <p:spTree>
+      <p:nvGrpSpPr>
+        <p:cNvPr id="1" name=""/>
+        <p:cNvGrpSpPr/>
+        <p:nvPr/>
+      </p:nvGrpSpPr>
+      <p:grpSpPr/>
       <p:sp>
         <p:nvSpPr>
           <p:cNvPr id="2" name="Rectangle 1"/>
@@ -5377,12 +5383,6 @@
           </a:p>
         </p:txBody>
       </p:sp>
-      <p:nvGrpSpPr>
-        <p:cNvPr id="1" name=""/>
-        <p:cNvGrpSpPr/>
-        <p:nvPr/>
-      </p:nvGrpSpPr>
-      <p:grpSpPr/>
       <p:sp>
         <p:nvSpPr>
           <p:cNvPr id="3" name="Rectangle 2"/>
@@ -5870,6 +5870,12 @@
 <p:sld xmlns:a="http://schemas.openxmlformats.org/drawingml/2006/main" xmlns:p="http://schemas.openxmlformats.org/presentationml/2006/main" xmlns:r="http://schemas.openxmlformats.org/officeDocument/2006/relationships">
   <p:cSld>
     <p:spTree>
+      <p:nvGrpSpPr>
+        <p:cNvPr id="1" name=""/>
+        <p:cNvGrpSpPr/>
+        <p:nvPr/>
+      </p:nvGrpSpPr>
+      <p:grpSpPr/>
       <p:sp>
         <p:nvSpPr>
           <p:cNvPr id="2" name="Rectangle 1"/>
@@ -5913,12 +5919,6 @@
           </a:p>
         </p:txBody>
       </p:sp>
-      <p:nvGrpSpPr>
-        <p:cNvPr id="1" name=""/>
-        <p:cNvGrpSpPr/>
-        <p:nvPr/>
-      </p:nvGrpSpPr>
-      <p:grpSpPr/>
       <p:sp>
         <p:nvSpPr>
           <p:cNvPr id="3" name="Rounded Rectangle 2"/>
@@ -6461,6 +6461,12 @@
 <p:sld xmlns:a="http://schemas.openxmlformats.org/drawingml/2006/main" xmlns:p="http://schemas.openxmlformats.org/presentationml/2006/main" xmlns:r="http://schemas.openxmlformats.org/officeDocument/2006/relationships">
   <p:cSld>
     <p:spTree>
+      <p:nvGrpSpPr>
+        <p:cNvPr id="1" name=""/>
+        <p:cNvGrpSpPr/>
+        <p:nvPr/>
+      </p:nvGrpSpPr>
+      <p:grpSpPr/>
       <p:sp>
         <p:nvSpPr>
           <p:cNvPr id="2" name="Rectangle 1"/>
@@ -6504,12 +6510,6 @@
           </a:p>
         </p:txBody>
       </p:sp>
-      <p:nvGrpSpPr>
-        <p:cNvPr id="1" name=""/>
-        <p:cNvGrpSpPr/>
-        <p:nvPr/>
-      </p:nvGrpSpPr>
-      <p:grpSpPr/>
       <p:sp>
         <p:nvSpPr>
           <p:cNvPr id="3" name="TextBox 2"/>

</xml_diff>

<commit_message>
Cập nhật Lịch báo giảng Tuần 30-35, slide bài giảng v3 Tin học (Tiền TH - Lớp 8) và các script hỗ trợ
</commit_message>
<xml_diff>
--- a/KHBD_Tin_học/Lớp_1/Tuần_02/Slide_Tin_hoc_Lop_1_Bai01_Chiec_may_tinh_cua_em.pptx
+++ b/KHBD_Tin_học/Lớp_1/Tuần_02/Slide_Tin_hoc_Lop_1_Bai01_Chiec_may_tinh_cua_em.pptx
@@ -3489,8 +3489,8 @@
         </p:nvSpPr>
         <p:spPr>
           <a:xfrm>
-            <a:off x="1371600" y="2011680"/>
-            <a:ext cx="9445752" cy="1371600"/>
+            <a:off x="731520" y="1828800"/>
+            <a:ext cx="6858000" cy="1371600"/>
           </a:xfrm>
           <a:prstGeom prst="rect">
             <a:avLst/>
@@ -3503,9 +3503,9 @@
           </a:bodyPr>
           <a:lstStyle/>
           <a:p>
-            <a:pPr algn="ctr"/>
-            <a:r>
-              <a:rPr sz="3600" b="1">
+            <a:pPr algn="l"/>
+            <a:r>
+              <a:rPr sz="3400" b="1">
                 <a:solidFill>
                   <a:srgbClr val="FFFFFF"/>
                 </a:solidFill>
@@ -3524,8 +3524,8 @@
         </p:nvSpPr>
         <p:spPr>
           <a:xfrm>
-            <a:off x="1371600" y="3657600"/>
-            <a:ext cx="9445752" cy="731520"/>
+            <a:off x="731520" y="3474720"/>
+            <a:ext cx="6858000" cy="731520"/>
           </a:xfrm>
           <a:prstGeom prst="rect">
             <a:avLst/>
@@ -3538,7 +3538,7 @@
           </a:bodyPr>
           <a:lstStyle/>
           <a:p>
-            <a:pPr algn="ctr"/>
+            <a:pPr algn="l"/>
             <a:r>
               <a:rPr sz="2000" b="0">
                 <a:solidFill>
@@ -3553,7 +3553,7 @@
       </p:sp>
       <p:pic>
         <p:nvPicPr>
-          <p:cNvPr id="6" name="Picture 5" descr="cover.png"/>
+          <p:cNvPr id="6" name="Picture 5" descr="activity.png"/>
           <p:cNvPicPr>
             <a:picLocks noChangeAspect="1"/>
           </p:cNvPicPr>
@@ -3726,7 +3726,7 @@
         <p:spPr>
           <a:xfrm>
             <a:off x="457200" y="1600200"/>
-            <a:ext cx="11274552" cy="594360"/>
+            <a:ext cx="7315200" cy="594360"/>
           </a:xfrm>
           <a:prstGeom prst="rect">
             <a:avLst/>
@@ -3846,8 +3846,8 @@
         </p:nvSpPr>
         <p:spPr>
           <a:xfrm>
-            <a:off x="731520" y="2423160"/>
-            <a:ext cx="6309360" cy="3108960"/>
+            <a:off x="731520" y="2468880"/>
+            <a:ext cx="6309360" cy="3017520"/>
           </a:xfrm>
           <a:prstGeom prst="rect">
             <a:avLst/>
@@ -3866,7 +3866,7 @@
               </a:spcAft>
             </a:pPr>
             <a:r>
-              <a:rPr sz="1800" b="0">
+              <a:rPr sz="2000" b="0">
                 <a:solidFill>
                   <a:srgbClr val="2E1065"/>
                 </a:solidFill>
@@ -3882,7 +3882,7 @@
               </a:spcAft>
             </a:pPr>
             <a:r>
-              <a:rPr sz="1800" b="0">
+              <a:rPr sz="2000" b="0">
                 <a:solidFill>
                   <a:srgbClr val="2E1065"/>
                 </a:solidFill>
@@ -3898,7 +3898,7 @@
               </a:spcAft>
             </a:pPr>
             <a:r>
-              <a:rPr sz="1800" b="0">
+              <a:rPr sz="2000" b="0">
                 <a:solidFill>
                   <a:srgbClr val="2E1065"/>
                 </a:solidFill>
@@ -3911,7 +3911,7 @@
       </p:sp>
       <p:pic>
         <p:nvPicPr>
-          <p:cNvPr id="9" name="Picture 8" descr="cover.png"/>
+          <p:cNvPr id="9" name="Picture 8" descr="activity.png"/>
           <p:cNvPicPr>
             <a:picLocks noChangeAspect="1"/>
           </p:cNvPicPr>
@@ -4118,8 +4118,8 @@
         </p:nvSpPr>
         <p:spPr>
           <a:xfrm>
-            <a:off x="365760" y="2286000"/>
-            <a:ext cx="6858000" cy="3383279"/>
+            <a:off x="457200" y="2628900"/>
+            <a:ext cx="3605784" cy="2788920"/>
           </a:xfrm>
           <a:prstGeom prst="roundRect">
             <a:avLst/>
@@ -4127,8 +4127,10 @@
           <a:solidFill>
             <a:srgbClr val="FFFFFF"/>
           </a:solidFill>
-          <a:ln>
-            <a:noFill/>
+          <a:ln w="12700">
+            <a:solidFill>
+              <a:srgbClr val="D0D5DD"/>
+            </a:solidFill>
           </a:ln>
         </p:spPr>
         <p:style>
@@ -4161,8 +4163,8 @@
         </p:nvSpPr>
         <p:spPr>
           <a:xfrm>
-            <a:off x="365760" y="2286000"/>
-            <a:ext cx="109728" cy="3383279"/>
+            <a:off x="457200" y="2628900"/>
+            <a:ext cx="3605784" cy="91440"/>
           </a:xfrm>
           <a:prstGeom prst="rect">
             <a:avLst/>
@@ -4196,96 +4198,9 @@
           </a:p>
         </p:txBody>
       </p:sp>
-      <p:sp>
-        <p:nvSpPr>
-          <p:cNvPr id="8" name="TextBox 7"/>
-          <p:cNvSpPr txBox="1"/>
-          <p:nvPr/>
-        </p:nvSpPr>
-        <p:spPr>
-          <a:xfrm>
-            <a:off x="731520" y="2423160"/>
-            <a:ext cx="6309360" cy="3108960"/>
-          </a:xfrm>
-          <a:prstGeom prst="rect">
-            <a:avLst/>
-          </a:prstGeom>
-          <a:noFill/>
-        </p:spPr>
-        <p:txBody>
-          <a:bodyPr wrap="square">
-            <a:spAutoFit/>
-          </a:bodyPr>
-          <a:lstStyle/>
-          <a:p>
-            <a:pPr algn="l">
-              <a:spcAft>
-                <a:spcPts val="600"/>
-              </a:spcAft>
-            </a:pPr>
-            <a:r>
-              <a:rPr sz="1800" b="0">
-                <a:solidFill>
-                  <a:srgbClr val="2E1065"/>
-                </a:solidFill>
-                <a:latin typeface="Arial"/>
-              </a:rPr>
-              <a:t>Máy tính có nhiều loại:</a:t>
-            </a:r>
-          </a:p>
-          <a:p>
-            <a:pPr algn="l">
-              <a:spcAft>
-                <a:spcPts val="600"/>
-              </a:spcAft>
-            </a:pPr>
-            <a:r>
-              <a:rPr sz="1800" b="0">
-                <a:solidFill>
-                  <a:srgbClr val="2E1065"/>
-                </a:solidFill>
-                <a:latin typeface="Arial"/>
-              </a:rPr>
-              <a:t>● Máy tính để bàn (Desktop)</a:t>
-            </a:r>
-          </a:p>
-          <a:p>
-            <a:pPr algn="l">
-              <a:spcAft>
-                <a:spcPts val="600"/>
-              </a:spcAft>
-            </a:pPr>
-            <a:r>
-              <a:rPr sz="1800" b="0">
-                <a:solidFill>
-                  <a:srgbClr val="2E1065"/>
-                </a:solidFill>
-                <a:latin typeface="Arial"/>
-              </a:rPr>
-              <a:t>● Máy tính xách tay (Laptop)</a:t>
-            </a:r>
-          </a:p>
-          <a:p>
-            <a:pPr algn="l">
-              <a:spcAft>
-                <a:spcPts val="600"/>
-              </a:spcAft>
-            </a:pPr>
-            <a:r>
-              <a:rPr sz="1800" b="0">
-                <a:solidFill>
-                  <a:srgbClr val="2E1065"/>
-                </a:solidFill>
-                <a:latin typeface="Arial"/>
-              </a:rPr>
-              <a:t>● Máy tính bảng (Tablet)</a:t>
-            </a:r>
-          </a:p>
-        </p:txBody>
-      </p:sp>
       <p:pic>
         <p:nvPicPr>
-          <p:cNvPr id="9" name="Picture 8" descr="activity.png"/>
+          <p:cNvPr id="8" name="Picture 7" descr="activity.png"/>
           <p:cNvPicPr>
             <a:picLocks noChangeAspect="1"/>
           </p:cNvPicPr>
@@ -4299,21 +4214,350 @@
         </p:blipFill>
         <p:spPr>
           <a:xfrm>
-            <a:off x="7589520" y="2286000"/>
-            <a:ext cx="4114799" cy="3383279"/>
+            <a:off x="1437132" y="2766060"/>
+            <a:ext cx="1645920" cy="1828800"/>
           </a:xfrm>
           <a:prstGeom prst="rect">
             <a:avLst/>
           </a:prstGeom>
         </p:spPr>
       </p:pic>
+      <p:sp>
+        <p:nvSpPr>
+          <p:cNvPr id="9" name="TextBox 8"/>
+          <p:cNvSpPr txBox="1"/>
+          <p:nvPr/>
+        </p:nvSpPr>
+        <p:spPr>
+          <a:xfrm>
+            <a:off x="594360" y="4594860"/>
+            <a:ext cx="3331464" cy="822960"/>
+          </a:xfrm>
+          <a:prstGeom prst="rect">
+            <a:avLst/>
+          </a:prstGeom>
+          <a:noFill/>
+        </p:spPr>
+        <p:txBody>
+          <a:bodyPr wrap="square">
+            <a:spAutoFit/>
+          </a:bodyPr>
+          <a:lstStyle/>
+          <a:p>
+            <a:pPr algn="ctr"/>
+            <a:r>
+              <a:rPr sz="1600" b="0">
+                <a:solidFill>
+                  <a:srgbClr val="2E1065"/>
+                </a:solidFill>
+                <a:latin typeface="Arial"/>
+              </a:rPr>
+              <a:t>Máy tính để bàn (Desktop)</a:t>
+            </a:r>
+          </a:p>
+        </p:txBody>
+      </p:sp>
+      <p:sp>
+        <p:nvSpPr>
+          <p:cNvPr id="10" name="Rounded Rectangle 9"/>
+          <p:cNvSpPr/>
+          <p:nvPr/>
+        </p:nvSpPr>
+        <p:spPr>
+          <a:xfrm>
+            <a:off x="4291584" y="2628900"/>
+            <a:ext cx="3605784" cy="2788920"/>
+          </a:xfrm>
+          <a:prstGeom prst="roundRect">
+            <a:avLst/>
+          </a:prstGeom>
+          <a:solidFill>
+            <a:srgbClr val="FFFFFF"/>
+          </a:solidFill>
+          <a:ln w="12700">
+            <a:solidFill>
+              <a:srgbClr val="D0D5DD"/>
+            </a:solidFill>
+          </a:ln>
+        </p:spPr>
+        <p:style>
+          <a:lnRef idx="1">
+            <a:schemeClr val="accent1"/>
+          </a:lnRef>
+          <a:fillRef idx="3">
+            <a:schemeClr val="accent1"/>
+          </a:fillRef>
+          <a:effectRef idx="2">
+            <a:schemeClr val="accent1"/>
+          </a:effectRef>
+          <a:fontRef idx="minor">
+            <a:schemeClr val="lt1"/>
+          </a:fontRef>
+        </p:style>
+        <p:txBody>
+          <a:bodyPr rtlCol="0" anchor="ctr"/>
+          <a:lstStyle/>
+          <a:p>
+            <a:pPr algn="ctr"/>
+          </a:p>
+        </p:txBody>
+      </p:sp>
+      <p:sp>
+        <p:nvSpPr>
+          <p:cNvPr id="11" name="Rectangle 10"/>
+          <p:cNvSpPr/>
+          <p:nvPr/>
+        </p:nvSpPr>
+        <p:spPr>
+          <a:xfrm>
+            <a:off x="4291584" y="2628900"/>
+            <a:ext cx="3605784" cy="91440"/>
+          </a:xfrm>
+          <a:prstGeom prst="rect">
+            <a:avLst/>
+          </a:prstGeom>
+          <a:solidFill>
+            <a:srgbClr val="7C3AED"/>
+          </a:solidFill>
+          <a:ln>
+            <a:noFill/>
+          </a:ln>
+        </p:spPr>
+        <p:style>
+          <a:lnRef idx="1">
+            <a:schemeClr val="accent1"/>
+          </a:lnRef>
+          <a:fillRef idx="3">
+            <a:schemeClr val="accent1"/>
+          </a:fillRef>
+          <a:effectRef idx="2">
+            <a:schemeClr val="accent1"/>
+          </a:effectRef>
+          <a:fontRef idx="minor">
+            <a:schemeClr val="lt1"/>
+          </a:fontRef>
+        </p:style>
+        <p:txBody>
+          <a:bodyPr rtlCol="0" anchor="ctr"/>
+          <a:lstStyle/>
+          <a:p>
+            <a:pPr algn="ctr"/>
+          </a:p>
+        </p:txBody>
+      </p:sp>
+      <p:pic>
+        <p:nvPicPr>
+          <p:cNvPr id="12" name="Picture 11" descr="cover.png"/>
+          <p:cNvPicPr>
+            <a:picLocks noChangeAspect="1"/>
+          </p:cNvPicPr>
+          <p:nvPr/>
+        </p:nvPicPr>
+        <p:blipFill>
+          <a:blip r:embed="rId3"/>
+          <a:stretch>
+            <a:fillRect/>
+          </a:stretch>
+        </p:blipFill>
+        <p:spPr>
+          <a:xfrm>
+            <a:off x="5271516" y="2766060"/>
+            <a:ext cx="1645920" cy="1828800"/>
+          </a:xfrm>
+          <a:prstGeom prst="rect">
+            <a:avLst/>
+          </a:prstGeom>
+        </p:spPr>
+      </p:pic>
+      <p:sp>
+        <p:nvSpPr>
+          <p:cNvPr id="13" name="TextBox 12"/>
+          <p:cNvSpPr txBox="1"/>
+          <p:nvPr/>
+        </p:nvSpPr>
+        <p:spPr>
+          <a:xfrm>
+            <a:off x="4428744" y="4594860"/>
+            <a:ext cx="3331464" cy="822960"/>
+          </a:xfrm>
+          <a:prstGeom prst="rect">
+            <a:avLst/>
+          </a:prstGeom>
+          <a:noFill/>
+        </p:spPr>
+        <p:txBody>
+          <a:bodyPr wrap="square">
+            <a:spAutoFit/>
+          </a:bodyPr>
+          <a:lstStyle/>
+          <a:p>
+            <a:pPr algn="ctr"/>
+            <a:r>
+              <a:rPr sz="1600" b="0">
+                <a:solidFill>
+                  <a:srgbClr val="2E1065"/>
+                </a:solidFill>
+                <a:latin typeface="Arial"/>
+              </a:rPr>
+              <a:t>Máy tính xách tay (Laptop)</a:t>
+            </a:r>
+          </a:p>
+        </p:txBody>
+      </p:sp>
+      <p:sp>
+        <p:nvSpPr>
+          <p:cNvPr id="14" name="Rounded Rectangle 13"/>
+          <p:cNvSpPr/>
+          <p:nvPr/>
+        </p:nvSpPr>
+        <p:spPr>
+          <a:xfrm>
+            <a:off x="8125968" y="2628900"/>
+            <a:ext cx="3605784" cy="2788920"/>
+          </a:xfrm>
+          <a:prstGeom prst="roundRect">
+            <a:avLst/>
+          </a:prstGeom>
+          <a:solidFill>
+            <a:srgbClr val="FFFFFF"/>
+          </a:solidFill>
+          <a:ln w="12700">
+            <a:solidFill>
+              <a:srgbClr val="D0D5DD"/>
+            </a:solidFill>
+          </a:ln>
+        </p:spPr>
+        <p:style>
+          <a:lnRef idx="1">
+            <a:schemeClr val="accent1"/>
+          </a:lnRef>
+          <a:fillRef idx="3">
+            <a:schemeClr val="accent1"/>
+          </a:fillRef>
+          <a:effectRef idx="2">
+            <a:schemeClr val="accent1"/>
+          </a:effectRef>
+          <a:fontRef idx="minor">
+            <a:schemeClr val="lt1"/>
+          </a:fontRef>
+        </p:style>
+        <p:txBody>
+          <a:bodyPr rtlCol="0" anchor="ctr"/>
+          <a:lstStyle/>
+          <a:p>
+            <a:pPr algn="ctr"/>
+          </a:p>
+        </p:txBody>
+      </p:sp>
+      <p:sp>
+        <p:nvSpPr>
+          <p:cNvPr id="15" name="Rectangle 14"/>
+          <p:cNvSpPr/>
+          <p:nvPr/>
+        </p:nvSpPr>
+        <p:spPr>
+          <a:xfrm>
+            <a:off x="8125968" y="2628900"/>
+            <a:ext cx="3605784" cy="91440"/>
+          </a:xfrm>
+          <a:prstGeom prst="rect">
+            <a:avLst/>
+          </a:prstGeom>
+          <a:solidFill>
+            <a:srgbClr val="7C3AED"/>
+          </a:solidFill>
+          <a:ln>
+            <a:noFill/>
+          </a:ln>
+        </p:spPr>
+        <p:style>
+          <a:lnRef idx="1">
+            <a:schemeClr val="accent1"/>
+          </a:lnRef>
+          <a:fillRef idx="3">
+            <a:schemeClr val="accent1"/>
+          </a:fillRef>
+          <a:effectRef idx="2">
+            <a:schemeClr val="accent1"/>
+          </a:effectRef>
+          <a:fontRef idx="minor">
+            <a:schemeClr val="lt1"/>
+          </a:fontRef>
+        </p:style>
+        <p:txBody>
+          <a:bodyPr rtlCol="0" anchor="ctr"/>
+          <a:lstStyle/>
+          <a:p>
+            <a:pPr algn="ctr"/>
+          </a:p>
+        </p:txBody>
+      </p:sp>
+      <p:pic>
+        <p:nvPicPr>
+          <p:cNvPr id="16" name="Picture 15" descr="practice.png"/>
+          <p:cNvPicPr>
+            <a:picLocks noChangeAspect="1"/>
+          </p:cNvPicPr>
+          <p:nvPr/>
+        </p:nvPicPr>
+        <p:blipFill>
+          <a:blip r:embed="rId4"/>
+          <a:stretch>
+            <a:fillRect/>
+          </a:stretch>
+        </p:blipFill>
+        <p:spPr>
+          <a:xfrm>
+            <a:off x="9105900" y="2766060"/>
+            <a:ext cx="1645920" cy="1828800"/>
+          </a:xfrm>
+          <a:prstGeom prst="rect">
+            <a:avLst/>
+          </a:prstGeom>
+        </p:spPr>
+      </p:pic>
+      <p:sp>
+        <p:nvSpPr>
+          <p:cNvPr id="17" name="TextBox 16"/>
+          <p:cNvSpPr txBox="1"/>
+          <p:nvPr/>
+        </p:nvSpPr>
+        <p:spPr>
+          <a:xfrm>
+            <a:off x="8263128" y="4594860"/>
+            <a:ext cx="3331464" cy="822960"/>
+          </a:xfrm>
+          <a:prstGeom prst="rect">
+            <a:avLst/>
+          </a:prstGeom>
+          <a:noFill/>
+        </p:spPr>
+        <p:txBody>
+          <a:bodyPr wrap="square">
+            <a:spAutoFit/>
+          </a:bodyPr>
+          <a:lstStyle/>
+          <a:p>
+            <a:pPr algn="ctr"/>
+            <a:r>
+              <a:rPr sz="1600" b="0">
+                <a:solidFill>
+                  <a:srgbClr val="2E1065"/>
+                </a:solidFill>
+                <a:latin typeface="Arial"/>
+              </a:rPr>
+              <a:t>Máy tính bảng (Tablet)</a:t>
+            </a:r>
+          </a:p>
+        </p:txBody>
+      </p:sp>
     </p:spTree>
   </p:cSld>
   <p:clrMapOvr>
     <a:masterClrMapping/>
   </p:clrMapOvr>
   <p:transition spd="med">
-    <p:push dir="l"/>
+    <p:wipe/>
   </p:transition>
 </p:sld>
 </file>
@@ -4492,8 +4736,8 @@
         </p:nvSpPr>
         <p:spPr>
           <a:xfrm>
-            <a:off x="365760" y="2286000"/>
-            <a:ext cx="6858000" cy="3383279"/>
+            <a:off x="457200" y="2331720"/>
+            <a:ext cx="5522976" cy="1600200"/>
           </a:xfrm>
           <a:prstGeom prst="roundRect">
             <a:avLst/>
@@ -4501,8 +4745,10 @@
           <a:solidFill>
             <a:srgbClr val="FFFFFF"/>
           </a:solidFill>
-          <a:ln>
-            <a:noFill/>
+          <a:ln w="12700">
+            <a:solidFill>
+              <a:srgbClr val="D0D5DD"/>
+            </a:solidFill>
           </a:ln>
         </p:spPr>
         <p:style>
@@ -4535,8 +4781,8 @@
         </p:nvSpPr>
         <p:spPr>
           <a:xfrm>
-            <a:off x="365760" y="2286000"/>
-            <a:ext cx="109728" cy="3383279"/>
+            <a:off x="457200" y="2331720"/>
+            <a:ext cx="5522976" cy="91440"/>
           </a:xfrm>
           <a:prstGeom prst="rect">
             <a:avLst/>
@@ -4570,96 +4816,9 @@
           </a:p>
         </p:txBody>
       </p:sp>
-      <p:sp>
-        <p:nvSpPr>
-          <p:cNvPr id="8" name="TextBox 7"/>
-          <p:cNvSpPr txBox="1"/>
-          <p:nvPr/>
-        </p:nvSpPr>
-        <p:spPr>
-          <a:xfrm>
-            <a:off x="731520" y="2423160"/>
-            <a:ext cx="6309360" cy="3108960"/>
-          </a:xfrm>
-          <a:prstGeom prst="rect">
-            <a:avLst/>
-          </a:prstGeom>
-          <a:noFill/>
-        </p:spPr>
-        <p:txBody>
-          <a:bodyPr wrap="square">
-            <a:spAutoFit/>
-          </a:bodyPr>
-          <a:lstStyle/>
-          <a:p>
-            <a:pPr algn="l">
-              <a:spcAft>
-                <a:spcPts val="600"/>
-              </a:spcAft>
-            </a:pPr>
-            <a:r>
-              <a:rPr sz="1800" b="0">
-                <a:solidFill>
-                  <a:srgbClr val="2E1065"/>
-                </a:solidFill>
-                <a:latin typeface="Arial"/>
-              </a:rPr>
-              <a:t>● Màn hình — hiển thị hình ảnh, chữ</a:t>
-            </a:r>
-          </a:p>
-          <a:p>
-            <a:pPr algn="l">
-              <a:spcAft>
-                <a:spcPts val="600"/>
-              </a:spcAft>
-            </a:pPr>
-            <a:r>
-              <a:rPr sz="1800" b="0">
-                <a:solidFill>
-                  <a:srgbClr val="2E1065"/>
-                </a:solidFill>
-                <a:latin typeface="Arial"/>
-              </a:rPr>
-              <a:t>● Bàn phím — em gõ chữ, số</a:t>
-            </a:r>
-          </a:p>
-          <a:p>
-            <a:pPr algn="l">
-              <a:spcAft>
-                <a:spcPts val="600"/>
-              </a:spcAft>
-            </a:pPr>
-            <a:r>
-              <a:rPr sz="1800" b="0">
-                <a:solidFill>
-                  <a:srgbClr val="2E1065"/>
-                </a:solidFill>
-                <a:latin typeface="Arial"/>
-              </a:rPr>
-              <a:t>● Chuột — em nhấp để chọn</a:t>
-            </a:r>
-          </a:p>
-          <a:p>
-            <a:pPr algn="l">
-              <a:spcAft>
-                <a:spcPts val="600"/>
-              </a:spcAft>
-            </a:pPr>
-            <a:r>
-              <a:rPr sz="1800" b="0">
-                <a:solidFill>
-                  <a:srgbClr val="2E1065"/>
-                </a:solidFill>
-                <a:latin typeface="Arial"/>
-              </a:rPr>
-              <a:t>● Thân máy — nơi xử lý thông tin</a:t>
-            </a:r>
-          </a:p>
-        </p:txBody>
-      </p:sp>
       <p:pic>
         <p:nvPicPr>
-          <p:cNvPr id="9" name="Picture 8" descr="activity.png"/>
+          <p:cNvPr id="8" name="Picture 7" descr="summary.png"/>
           <p:cNvPicPr>
             <a:picLocks noChangeAspect="1"/>
           </p:cNvPicPr>
@@ -4673,14 +4832,490 @@
         </p:blipFill>
         <p:spPr>
           <a:xfrm>
-            <a:off x="7589520" y="2286000"/>
-            <a:ext cx="4114799" cy="3383279"/>
+            <a:off x="2395728" y="2468879"/>
+            <a:ext cx="1645920" cy="1005840"/>
           </a:xfrm>
           <a:prstGeom prst="rect">
             <a:avLst/>
           </a:prstGeom>
         </p:spPr>
       </p:pic>
+      <p:sp>
+        <p:nvSpPr>
+          <p:cNvPr id="9" name="TextBox 8"/>
+          <p:cNvSpPr txBox="1"/>
+          <p:nvPr/>
+        </p:nvSpPr>
+        <p:spPr>
+          <a:xfrm>
+            <a:off x="594360" y="3474720"/>
+            <a:ext cx="5248656" cy="457200"/>
+          </a:xfrm>
+          <a:prstGeom prst="rect">
+            <a:avLst/>
+          </a:prstGeom>
+          <a:noFill/>
+        </p:spPr>
+        <p:txBody>
+          <a:bodyPr wrap="square">
+            <a:spAutoFit/>
+          </a:bodyPr>
+          <a:lstStyle/>
+          <a:p>
+            <a:pPr algn="ctr"/>
+            <a:r>
+              <a:rPr sz="1600" b="0">
+                <a:solidFill>
+                  <a:srgbClr val="2E1065"/>
+                </a:solidFill>
+                <a:latin typeface="Arial"/>
+              </a:rPr>
+              <a:t>Màn hình — hiển thị hình ảnh, chữ</a:t>
+            </a:r>
+          </a:p>
+        </p:txBody>
+      </p:sp>
+      <p:sp>
+        <p:nvSpPr>
+          <p:cNvPr id="10" name="Rounded Rectangle 9"/>
+          <p:cNvSpPr/>
+          <p:nvPr/>
+        </p:nvSpPr>
+        <p:spPr>
+          <a:xfrm>
+            <a:off x="6208776" y="2331720"/>
+            <a:ext cx="5522976" cy="1600200"/>
+          </a:xfrm>
+          <a:prstGeom prst="roundRect">
+            <a:avLst/>
+          </a:prstGeom>
+          <a:solidFill>
+            <a:srgbClr val="FFFFFF"/>
+          </a:solidFill>
+          <a:ln w="12700">
+            <a:solidFill>
+              <a:srgbClr val="D0D5DD"/>
+            </a:solidFill>
+          </a:ln>
+        </p:spPr>
+        <p:style>
+          <a:lnRef idx="1">
+            <a:schemeClr val="accent1"/>
+          </a:lnRef>
+          <a:fillRef idx="3">
+            <a:schemeClr val="accent1"/>
+          </a:fillRef>
+          <a:effectRef idx="2">
+            <a:schemeClr val="accent1"/>
+          </a:effectRef>
+          <a:fontRef idx="minor">
+            <a:schemeClr val="lt1"/>
+          </a:fontRef>
+        </p:style>
+        <p:txBody>
+          <a:bodyPr rtlCol="0" anchor="ctr"/>
+          <a:lstStyle/>
+          <a:p>
+            <a:pPr algn="ctr"/>
+          </a:p>
+        </p:txBody>
+      </p:sp>
+      <p:sp>
+        <p:nvSpPr>
+          <p:cNvPr id="11" name="Rectangle 10"/>
+          <p:cNvSpPr/>
+          <p:nvPr/>
+        </p:nvSpPr>
+        <p:spPr>
+          <a:xfrm>
+            <a:off x="6208776" y="2331720"/>
+            <a:ext cx="5522976" cy="91440"/>
+          </a:xfrm>
+          <a:prstGeom prst="rect">
+            <a:avLst/>
+          </a:prstGeom>
+          <a:solidFill>
+            <a:srgbClr val="7C3AED"/>
+          </a:solidFill>
+          <a:ln>
+            <a:noFill/>
+          </a:ln>
+        </p:spPr>
+        <p:style>
+          <a:lnRef idx="1">
+            <a:schemeClr val="accent1"/>
+          </a:lnRef>
+          <a:fillRef idx="3">
+            <a:schemeClr val="accent1"/>
+          </a:fillRef>
+          <a:effectRef idx="2">
+            <a:schemeClr val="accent1"/>
+          </a:effectRef>
+          <a:fontRef idx="minor">
+            <a:schemeClr val="lt1"/>
+          </a:fontRef>
+        </p:style>
+        <p:txBody>
+          <a:bodyPr rtlCol="0" anchor="ctr"/>
+          <a:lstStyle/>
+          <a:p>
+            <a:pPr algn="ctr"/>
+          </a:p>
+        </p:txBody>
+      </p:sp>
+      <p:pic>
+        <p:nvPicPr>
+          <p:cNvPr id="12" name="Picture 11" descr="activity.png"/>
+          <p:cNvPicPr>
+            <a:picLocks noChangeAspect="1"/>
+          </p:cNvPicPr>
+          <p:nvPr/>
+        </p:nvPicPr>
+        <p:blipFill>
+          <a:blip r:embed="rId3"/>
+          <a:stretch>
+            <a:fillRect/>
+          </a:stretch>
+        </p:blipFill>
+        <p:spPr>
+          <a:xfrm>
+            <a:off x="8147304" y="2468879"/>
+            <a:ext cx="1645920" cy="1005840"/>
+          </a:xfrm>
+          <a:prstGeom prst="rect">
+            <a:avLst/>
+          </a:prstGeom>
+        </p:spPr>
+      </p:pic>
+      <p:sp>
+        <p:nvSpPr>
+          <p:cNvPr id="13" name="TextBox 12"/>
+          <p:cNvSpPr txBox="1"/>
+          <p:nvPr/>
+        </p:nvSpPr>
+        <p:spPr>
+          <a:xfrm>
+            <a:off x="6345936" y="3474720"/>
+            <a:ext cx="5248656" cy="457200"/>
+          </a:xfrm>
+          <a:prstGeom prst="rect">
+            <a:avLst/>
+          </a:prstGeom>
+          <a:noFill/>
+        </p:spPr>
+        <p:txBody>
+          <a:bodyPr wrap="square">
+            <a:spAutoFit/>
+          </a:bodyPr>
+          <a:lstStyle/>
+          <a:p>
+            <a:pPr algn="ctr"/>
+            <a:r>
+              <a:rPr sz="1600" b="0">
+                <a:solidFill>
+                  <a:srgbClr val="2E1065"/>
+                </a:solidFill>
+                <a:latin typeface="Arial"/>
+              </a:rPr>
+              <a:t>Bàn phím — em gõ chữ, số</a:t>
+            </a:r>
+          </a:p>
+        </p:txBody>
+      </p:sp>
+      <p:sp>
+        <p:nvSpPr>
+          <p:cNvPr id="14" name="Rounded Rectangle 13"/>
+          <p:cNvSpPr/>
+          <p:nvPr/>
+        </p:nvSpPr>
+        <p:spPr>
+          <a:xfrm>
+            <a:off x="457200" y="4160520"/>
+            <a:ext cx="5522976" cy="1600200"/>
+          </a:xfrm>
+          <a:prstGeom prst="roundRect">
+            <a:avLst/>
+          </a:prstGeom>
+          <a:solidFill>
+            <a:srgbClr val="FFFFFF"/>
+          </a:solidFill>
+          <a:ln w="12700">
+            <a:solidFill>
+              <a:srgbClr val="D0D5DD"/>
+            </a:solidFill>
+          </a:ln>
+        </p:spPr>
+        <p:style>
+          <a:lnRef idx="1">
+            <a:schemeClr val="accent1"/>
+          </a:lnRef>
+          <a:fillRef idx="3">
+            <a:schemeClr val="accent1"/>
+          </a:fillRef>
+          <a:effectRef idx="2">
+            <a:schemeClr val="accent1"/>
+          </a:effectRef>
+          <a:fontRef idx="minor">
+            <a:schemeClr val="lt1"/>
+          </a:fontRef>
+        </p:style>
+        <p:txBody>
+          <a:bodyPr rtlCol="0" anchor="ctr"/>
+          <a:lstStyle/>
+          <a:p>
+            <a:pPr algn="ctr"/>
+          </a:p>
+        </p:txBody>
+      </p:sp>
+      <p:sp>
+        <p:nvSpPr>
+          <p:cNvPr id="15" name="Rectangle 14"/>
+          <p:cNvSpPr/>
+          <p:nvPr/>
+        </p:nvSpPr>
+        <p:spPr>
+          <a:xfrm>
+            <a:off x="457200" y="4160520"/>
+            <a:ext cx="5522976" cy="91440"/>
+          </a:xfrm>
+          <a:prstGeom prst="rect">
+            <a:avLst/>
+          </a:prstGeom>
+          <a:solidFill>
+            <a:srgbClr val="7C3AED"/>
+          </a:solidFill>
+          <a:ln>
+            <a:noFill/>
+          </a:ln>
+        </p:spPr>
+        <p:style>
+          <a:lnRef idx="1">
+            <a:schemeClr val="accent1"/>
+          </a:lnRef>
+          <a:fillRef idx="3">
+            <a:schemeClr val="accent1"/>
+          </a:fillRef>
+          <a:effectRef idx="2">
+            <a:schemeClr val="accent1"/>
+          </a:effectRef>
+          <a:fontRef idx="minor">
+            <a:schemeClr val="lt1"/>
+          </a:fontRef>
+        </p:style>
+        <p:txBody>
+          <a:bodyPr rtlCol="0" anchor="ctr"/>
+          <a:lstStyle/>
+          <a:p>
+            <a:pPr algn="ctr"/>
+          </a:p>
+        </p:txBody>
+      </p:sp>
+      <p:pic>
+        <p:nvPicPr>
+          <p:cNvPr id="16" name="Picture 15" descr="cover.png"/>
+          <p:cNvPicPr>
+            <a:picLocks noChangeAspect="1"/>
+          </p:cNvPicPr>
+          <p:nvPr/>
+        </p:nvPicPr>
+        <p:blipFill>
+          <a:blip r:embed="rId4"/>
+          <a:stretch>
+            <a:fillRect/>
+          </a:stretch>
+        </p:blipFill>
+        <p:spPr>
+          <a:xfrm>
+            <a:off x="2395728" y="4297680"/>
+            <a:ext cx="1645920" cy="1005840"/>
+          </a:xfrm>
+          <a:prstGeom prst="rect">
+            <a:avLst/>
+          </a:prstGeom>
+        </p:spPr>
+      </p:pic>
+      <p:sp>
+        <p:nvSpPr>
+          <p:cNvPr id="17" name="TextBox 16"/>
+          <p:cNvSpPr txBox="1"/>
+          <p:nvPr/>
+        </p:nvSpPr>
+        <p:spPr>
+          <a:xfrm>
+            <a:off x="594360" y="5303520"/>
+            <a:ext cx="5248656" cy="457200"/>
+          </a:xfrm>
+          <a:prstGeom prst="rect">
+            <a:avLst/>
+          </a:prstGeom>
+          <a:noFill/>
+        </p:spPr>
+        <p:txBody>
+          <a:bodyPr wrap="square">
+            <a:spAutoFit/>
+          </a:bodyPr>
+          <a:lstStyle/>
+          <a:p>
+            <a:pPr algn="ctr"/>
+            <a:r>
+              <a:rPr sz="1600" b="0">
+                <a:solidFill>
+                  <a:srgbClr val="2E1065"/>
+                </a:solidFill>
+                <a:latin typeface="Arial"/>
+              </a:rPr>
+              <a:t>Chuột — em nhấp để chọn</a:t>
+            </a:r>
+          </a:p>
+        </p:txBody>
+      </p:sp>
+      <p:sp>
+        <p:nvSpPr>
+          <p:cNvPr id="18" name="Rounded Rectangle 17"/>
+          <p:cNvSpPr/>
+          <p:nvPr/>
+        </p:nvSpPr>
+        <p:spPr>
+          <a:xfrm>
+            <a:off x="6208776" y="4160520"/>
+            <a:ext cx="5522976" cy="1600200"/>
+          </a:xfrm>
+          <a:prstGeom prst="roundRect">
+            <a:avLst/>
+          </a:prstGeom>
+          <a:solidFill>
+            <a:srgbClr val="FFFFFF"/>
+          </a:solidFill>
+          <a:ln w="12700">
+            <a:solidFill>
+              <a:srgbClr val="D0D5DD"/>
+            </a:solidFill>
+          </a:ln>
+        </p:spPr>
+        <p:style>
+          <a:lnRef idx="1">
+            <a:schemeClr val="accent1"/>
+          </a:lnRef>
+          <a:fillRef idx="3">
+            <a:schemeClr val="accent1"/>
+          </a:fillRef>
+          <a:effectRef idx="2">
+            <a:schemeClr val="accent1"/>
+          </a:effectRef>
+          <a:fontRef idx="minor">
+            <a:schemeClr val="lt1"/>
+          </a:fontRef>
+        </p:style>
+        <p:txBody>
+          <a:bodyPr rtlCol="0" anchor="ctr"/>
+          <a:lstStyle/>
+          <a:p>
+            <a:pPr algn="ctr"/>
+          </a:p>
+        </p:txBody>
+      </p:sp>
+      <p:sp>
+        <p:nvSpPr>
+          <p:cNvPr id="19" name="Rectangle 18"/>
+          <p:cNvSpPr/>
+          <p:nvPr/>
+        </p:nvSpPr>
+        <p:spPr>
+          <a:xfrm>
+            <a:off x="6208776" y="4160520"/>
+            <a:ext cx="5522976" cy="91440"/>
+          </a:xfrm>
+          <a:prstGeom prst="rect">
+            <a:avLst/>
+          </a:prstGeom>
+          <a:solidFill>
+            <a:srgbClr val="7C3AED"/>
+          </a:solidFill>
+          <a:ln>
+            <a:noFill/>
+          </a:ln>
+        </p:spPr>
+        <p:style>
+          <a:lnRef idx="1">
+            <a:schemeClr val="accent1"/>
+          </a:lnRef>
+          <a:fillRef idx="3">
+            <a:schemeClr val="accent1"/>
+          </a:fillRef>
+          <a:effectRef idx="2">
+            <a:schemeClr val="accent1"/>
+          </a:effectRef>
+          <a:fontRef idx="minor">
+            <a:schemeClr val="lt1"/>
+          </a:fontRef>
+        </p:style>
+        <p:txBody>
+          <a:bodyPr rtlCol="0" anchor="ctr"/>
+          <a:lstStyle/>
+          <a:p>
+            <a:pPr algn="ctr"/>
+          </a:p>
+        </p:txBody>
+      </p:sp>
+      <p:pic>
+        <p:nvPicPr>
+          <p:cNvPr id="20" name="Picture 19" descr="practice.png"/>
+          <p:cNvPicPr>
+            <a:picLocks noChangeAspect="1"/>
+          </p:cNvPicPr>
+          <p:nvPr/>
+        </p:nvPicPr>
+        <p:blipFill>
+          <a:blip r:embed="rId5"/>
+          <a:stretch>
+            <a:fillRect/>
+          </a:stretch>
+        </p:blipFill>
+        <p:spPr>
+          <a:xfrm>
+            <a:off x="8147304" y="4297680"/>
+            <a:ext cx="1645920" cy="1005840"/>
+          </a:xfrm>
+          <a:prstGeom prst="rect">
+            <a:avLst/>
+          </a:prstGeom>
+        </p:spPr>
+      </p:pic>
+      <p:sp>
+        <p:nvSpPr>
+          <p:cNvPr id="21" name="TextBox 20"/>
+          <p:cNvSpPr txBox="1"/>
+          <p:nvPr/>
+        </p:nvSpPr>
+        <p:spPr>
+          <a:xfrm>
+            <a:off x="6345936" y="5303520"/>
+            <a:ext cx="5248656" cy="457200"/>
+          </a:xfrm>
+          <a:prstGeom prst="rect">
+            <a:avLst/>
+          </a:prstGeom>
+          <a:noFill/>
+        </p:spPr>
+        <p:txBody>
+          <a:bodyPr wrap="square">
+            <a:spAutoFit/>
+          </a:bodyPr>
+          <a:lstStyle/>
+          <a:p>
+            <a:pPr algn="ctr"/>
+            <a:r>
+              <a:rPr sz="1600" b="0">
+                <a:solidFill>
+                  <a:srgbClr val="2E1065"/>
+                </a:solidFill>
+                <a:latin typeface="Arial"/>
+              </a:rPr>
+              <a:t>Thân máy — nơi xử lý thông tin</a:t>
+            </a:r>
+          </a:p>
+        </p:txBody>
+      </p:sp>
     </p:spTree>
   </p:cSld>
   <p:clrMapOvr>
@@ -4866,8 +5501,8 @@
         </p:nvSpPr>
         <p:spPr>
           <a:xfrm>
-            <a:off x="365760" y="2286000"/>
-            <a:ext cx="6858000" cy="3383279"/>
+            <a:off x="457200" y="2628900"/>
+            <a:ext cx="3605784" cy="2788920"/>
           </a:xfrm>
           <a:prstGeom prst="roundRect">
             <a:avLst/>
@@ -4875,8 +5510,10 @@
           <a:solidFill>
             <a:srgbClr val="FFFFFF"/>
           </a:solidFill>
-          <a:ln>
-            <a:noFill/>
+          <a:ln w="12700">
+            <a:solidFill>
+              <a:srgbClr val="D0D5DD"/>
+            </a:solidFill>
           </a:ln>
         </p:spPr>
         <p:style>
@@ -4909,8 +5546,8 @@
         </p:nvSpPr>
         <p:spPr>
           <a:xfrm>
-            <a:off x="365760" y="2286000"/>
-            <a:ext cx="109728" cy="3383279"/>
+            <a:off x="457200" y="2628900"/>
+            <a:ext cx="3605784" cy="91440"/>
           </a:xfrm>
           <a:prstGeom prst="rect">
             <a:avLst/>
@@ -4944,112 +5581,9 @@
           </a:p>
         </p:txBody>
       </p:sp>
-      <p:sp>
-        <p:nvSpPr>
-          <p:cNvPr id="8" name="TextBox 7"/>
-          <p:cNvSpPr txBox="1"/>
-          <p:nvPr/>
-        </p:nvSpPr>
-        <p:spPr>
-          <a:xfrm>
-            <a:off x="731520" y="2423160"/>
-            <a:ext cx="6309360" cy="3108960"/>
-          </a:xfrm>
-          <a:prstGeom prst="rect">
-            <a:avLst/>
-          </a:prstGeom>
-          <a:noFill/>
-        </p:spPr>
-        <p:txBody>
-          <a:bodyPr wrap="square">
-            <a:spAutoFit/>
-          </a:bodyPr>
-          <a:lstStyle/>
-          <a:p>
-            <a:pPr algn="l">
-              <a:spcAft>
-                <a:spcPts val="600"/>
-              </a:spcAft>
-            </a:pPr>
-            <a:r>
-              <a:rPr sz="1800" b="0">
-                <a:solidFill>
-                  <a:srgbClr val="2E1065"/>
-                </a:solidFill>
-                <a:latin typeface="Arial"/>
-              </a:rPr>
-              <a:t>Bước 1: Nhấn nút nguồn để bật</a:t>
-            </a:r>
-          </a:p>
-          <a:p>
-            <a:pPr algn="l">
-              <a:spcAft>
-                <a:spcPts val="600"/>
-              </a:spcAft>
-            </a:pPr>
-            <a:r>
-              <a:rPr sz="1800" b="0">
-                <a:solidFill>
-                  <a:srgbClr val="2E1065"/>
-                </a:solidFill>
-                <a:latin typeface="Arial"/>
-              </a:rPr>
-              <a:t>Bước 2: Chờ máy khởi động</a:t>
-            </a:r>
-          </a:p>
-          <a:p>
-            <a:pPr algn="l">
-              <a:spcAft>
-                <a:spcPts val="600"/>
-              </a:spcAft>
-            </a:pPr>
-            <a:r>
-              <a:rPr sz="1800" b="0">
-                <a:solidFill>
-                  <a:srgbClr val="2E1065"/>
-                </a:solidFill>
-                <a:latin typeface="Arial"/>
-              </a:rPr>
-              <a:t>Bước 3: Khi muốn tắt → chọn Shut Down</a:t>
-            </a:r>
-          </a:p>
-          <a:p>
-            <a:pPr algn="l">
-              <a:spcAft>
-                <a:spcPts val="600"/>
-              </a:spcAft>
-            </a:pPr>
-            <a:r>
-              <a:rPr sz="1800" b="0">
-                <a:solidFill>
-                  <a:srgbClr val="2E1065"/>
-                </a:solidFill>
-                <a:latin typeface="Arial"/>
-              </a:rPr>
-              <a:t/>
-            </a:r>
-          </a:p>
-          <a:p>
-            <a:pPr algn="l">
-              <a:spcAft>
-                <a:spcPts val="600"/>
-              </a:spcAft>
-            </a:pPr>
-            <a:r>
-              <a:rPr sz="1800" b="0">
-                <a:solidFill>
-                  <a:srgbClr val="2E1065"/>
-                </a:solidFill>
-                <a:latin typeface="Arial"/>
-              </a:rPr>
-              <a:t>Không rút dây điện đột ngột!</a:t>
-            </a:r>
-          </a:p>
-        </p:txBody>
-      </p:sp>
       <p:pic>
         <p:nvPicPr>
-          <p:cNvPr id="9" name="Picture 8" descr="activity.png"/>
+          <p:cNvPr id="8" name="Picture 7" descr="practice.png"/>
           <p:cNvPicPr>
             <a:picLocks noChangeAspect="1"/>
           </p:cNvPicPr>
@@ -5063,21 +5597,350 @@
         </p:blipFill>
         <p:spPr>
           <a:xfrm>
-            <a:off x="7589520" y="2286000"/>
-            <a:ext cx="4114799" cy="3383279"/>
+            <a:off x="1437132" y="2766060"/>
+            <a:ext cx="1645920" cy="1828800"/>
           </a:xfrm>
           <a:prstGeom prst="rect">
             <a:avLst/>
           </a:prstGeom>
         </p:spPr>
       </p:pic>
+      <p:sp>
+        <p:nvSpPr>
+          <p:cNvPr id="9" name="TextBox 8"/>
+          <p:cNvSpPr txBox="1"/>
+          <p:nvPr/>
+        </p:nvSpPr>
+        <p:spPr>
+          <a:xfrm>
+            <a:off x="594360" y="4594860"/>
+            <a:ext cx="3331464" cy="822960"/>
+          </a:xfrm>
+          <a:prstGeom prst="rect">
+            <a:avLst/>
+          </a:prstGeom>
+          <a:noFill/>
+        </p:spPr>
+        <p:txBody>
+          <a:bodyPr wrap="square">
+            <a:spAutoFit/>
+          </a:bodyPr>
+          <a:lstStyle/>
+          <a:p>
+            <a:pPr algn="ctr"/>
+            <a:r>
+              <a:rPr sz="1600" b="0">
+                <a:solidFill>
+                  <a:srgbClr val="2E1065"/>
+                </a:solidFill>
+                <a:latin typeface="Arial"/>
+              </a:rPr>
+              <a:t>Bước 1: Nhấn nút nguồn để bật máy</a:t>
+            </a:r>
+          </a:p>
+        </p:txBody>
+      </p:sp>
+      <p:sp>
+        <p:nvSpPr>
+          <p:cNvPr id="10" name="Rounded Rectangle 9"/>
+          <p:cNvSpPr/>
+          <p:nvPr/>
+        </p:nvSpPr>
+        <p:spPr>
+          <a:xfrm>
+            <a:off x="4291584" y="2628900"/>
+            <a:ext cx="3605784" cy="2788920"/>
+          </a:xfrm>
+          <a:prstGeom prst="roundRect">
+            <a:avLst/>
+          </a:prstGeom>
+          <a:solidFill>
+            <a:srgbClr val="FFFFFF"/>
+          </a:solidFill>
+          <a:ln w="12700">
+            <a:solidFill>
+              <a:srgbClr val="D0D5DD"/>
+            </a:solidFill>
+          </a:ln>
+        </p:spPr>
+        <p:style>
+          <a:lnRef idx="1">
+            <a:schemeClr val="accent1"/>
+          </a:lnRef>
+          <a:fillRef idx="3">
+            <a:schemeClr val="accent1"/>
+          </a:fillRef>
+          <a:effectRef idx="2">
+            <a:schemeClr val="accent1"/>
+          </a:effectRef>
+          <a:fontRef idx="minor">
+            <a:schemeClr val="lt1"/>
+          </a:fontRef>
+        </p:style>
+        <p:txBody>
+          <a:bodyPr rtlCol="0" anchor="ctr"/>
+          <a:lstStyle/>
+          <a:p>
+            <a:pPr algn="ctr"/>
+          </a:p>
+        </p:txBody>
+      </p:sp>
+      <p:sp>
+        <p:nvSpPr>
+          <p:cNvPr id="11" name="Rectangle 10"/>
+          <p:cNvSpPr/>
+          <p:nvPr/>
+        </p:nvSpPr>
+        <p:spPr>
+          <a:xfrm>
+            <a:off x="4291584" y="2628900"/>
+            <a:ext cx="3605784" cy="91440"/>
+          </a:xfrm>
+          <a:prstGeom prst="rect">
+            <a:avLst/>
+          </a:prstGeom>
+          <a:solidFill>
+            <a:srgbClr val="7C3AED"/>
+          </a:solidFill>
+          <a:ln>
+            <a:noFill/>
+          </a:ln>
+        </p:spPr>
+        <p:style>
+          <a:lnRef idx="1">
+            <a:schemeClr val="accent1"/>
+          </a:lnRef>
+          <a:fillRef idx="3">
+            <a:schemeClr val="accent1"/>
+          </a:fillRef>
+          <a:effectRef idx="2">
+            <a:schemeClr val="accent1"/>
+          </a:effectRef>
+          <a:fontRef idx="minor">
+            <a:schemeClr val="lt1"/>
+          </a:fontRef>
+        </p:style>
+        <p:txBody>
+          <a:bodyPr rtlCol="0" anchor="ctr"/>
+          <a:lstStyle/>
+          <a:p>
+            <a:pPr algn="ctr"/>
+          </a:p>
+        </p:txBody>
+      </p:sp>
+      <p:pic>
+        <p:nvPicPr>
+          <p:cNvPr id="12" name="Picture 11" descr="summary.png"/>
+          <p:cNvPicPr>
+            <a:picLocks noChangeAspect="1"/>
+          </p:cNvPicPr>
+          <p:nvPr/>
+        </p:nvPicPr>
+        <p:blipFill>
+          <a:blip r:embed="rId3"/>
+          <a:stretch>
+            <a:fillRect/>
+          </a:stretch>
+        </p:blipFill>
+        <p:spPr>
+          <a:xfrm>
+            <a:off x="5271516" y="2766060"/>
+            <a:ext cx="1645920" cy="1828800"/>
+          </a:xfrm>
+          <a:prstGeom prst="rect">
+            <a:avLst/>
+          </a:prstGeom>
+        </p:spPr>
+      </p:pic>
+      <p:sp>
+        <p:nvSpPr>
+          <p:cNvPr id="13" name="TextBox 12"/>
+          <p:cNvSpPr txBox="1"/>
+          <p:nvPr/>
+        </p:nvSpPr>
+        <p:spPr>
+          <a:xfrm>
+            <a:off x="4428744" y="4594860"/>
+            <a:ext cx="3331464" cy="822960"/>
+          </a:xfrm>
+          <a:prstGeom prst="rect">
+            <a:avLst/>
+          </a:prstGeom>
+          <a:noFill/>
+        </p:spPr>
+        <p:txBody>
+          <a:bodyPr wrap="square">
+            <a:spAutoFit/>
+          </a:bodyPr>
+          <a:lstStyle/>
+          <a:p>
+            <a:pPr algn="ctr"/>
+            <a:r>
+              <a:rPr sz="1600" b="0">
+                <a:solidFill>
+                  <a:srgbClr val="2E1065"/>
+                </a:solidFill>
+                <a:latin typeface="Arial"/>
+              </a:rPr>
+              <a:t>Bước 2: Chờ máy khởi động xong</a:t>
+            </a:r>
+          </a:p>
+        </p:txBody>
+      </p:sp>
+      <p:sp>
+        <p:nvSpPr>
+          <p:cNvPr id="14" name="Rounded Rectangle 13"/>
+          <p:cNvSpPr/>
+          <p:nvPr/>
+        </p:nvSpPr>
+        <p:spPr>
+          <a:xfrm>
+            <a:off x="8125968" y="2628900"/>
+            <a:ext cx="3605784" cy="2788920"/>
+          </a:xfrm>
+          <a:prstGeom prst="roundRect">
+            <a:avLst/>
+          </a:prstGeom>
+          <a:solidFill>
+            <a:srgbClr val="FFFFFF"/>
+          </a:solidFill>
+          <a:ln w="12700">
+            <a:solidFill>
+              <a:srgbClr val="D0D5DD"/>
+            </a:solidFill>
+          </a:ln>
+        </p:spPr>
+        <p:style>
+          <a:lnRef idx="1">
+            <a:schemeClr val="accent1"/>
+          </a:lnRef>
+          <a:fillRef idx="3">
+            <a:schemeClr val="accent1"/>
+          </a:fillRef>
+          <a:effectRef idx="2">
+            <a:schemeClr val="accent1"/>
+          </a:effectRef>
+          <a:fontRef idx="minor">
+            <a:schemeClr val="lt1"/>
+          </a:fontRef>
+        </p:style>
+        <p:txBody>
+          <a:bodyPr rtlCol="0" anchor="ctr"/>
+          <a:lstStyle/>
+          <a:p>
+            <a:pPr algn="ctr"/>
+          </a:p>
+        </p:txBody>
+      </p:sp>
+      <p:sp>
+        <p:nvSpPr>
+          <p:cNvPr id="15" name="Rectangle 14"/>
+          <p:cNvSpPr/>
+          <p:nvPr/>
+        </p:nvSpPr>
+        <p:spPr>
+          <a:xfrm>
+            <a:off x="8125968" y="2628900"/>
+            <a:ext cx="3605784" cy="91440"/>
+          </a:xfrm>
+          <a:prstGeom prst="rect">
+            <a:avLst/>
+          </a:prstGeom>
+          <a:solidFill>
+            <a:srgbClr val="7C3AED"/>
+          </a:solidFill>
+          <a:ln>
+            <a:noFill/>
+          </a:ln>
+        </p:spPr>
+        <p:style>
+          <a:lnRef idx="1">
+            <a:schemeClr val="accent1"/>
+          </a:lnRef>
+          <a:fillRef idx="3">
+            <a:schemeClr val="accent1"/>
+          </a:fillRef>
+          <a:effectRef idx="2">
+            <a:schemeClr val="accent1"/>
+          </a:effectRef>
+          <a:fontRef idx="minor">
+            <a:schemeClr val="lt1"/>
+          </a:fontRef>
+        </p:style>
+        <p:txBody>
+          <a:bodyPr rtlCol="0" anchor="ctr"/>
+          <a:lstStyle/>
+          <a:p>
+            <a:pPr algn="ctr"/>
+          </a:p>
+        </p:txBody>
+      </p:sp>
+      <p:pic>
+        <p:nvPicPr>
+          <p:cNvPr id="16" name="Picture 15" descr="activity.png"/>
+          <p:cNvPicPr>
+            <a:picLocks noChangeAspect="1"/>
+          </p:cNvPicPr>
+          <p:nvPr/>
+        </p:nvPicPr>
+        <p:blipFill>
+          <a:blip r:embed="rId4"/>
+          <a:stretch>
+            <a:fillRect/>
+          </a:stretch>
+        </p:blipFill>
+        <p:spPr>
+          <a:xfrm>
+            <a:off x="9105900" y="2766060"/>
+            <a:ext cx="1645920" cy="1828800"/>
+          </a:xfrm>
+          <a:prstGeom prst="rect">
+            <a:avLst/>
+          </a:prstGeom>
+        </p:spPr>
+      </p:pic>
+      <p:sp>
+        <p:nvSpPr>
+          <p:cNvPr id="17" name="TextBox 16"/>
+          <p:cNvSpPr txBox="1"/>
+          <p:nvPr/>
+        </p:nvSpPr>
+        <p:spPr>
+          <a:xfrm>
+            <a:off x="8263128" y="4594860"/>
+            <a:ext cx="3331464" cy="822960"/>
+          </a:xfrm>
+          <a:prstGeom prst="rect">
+            <a:avLst/>
+          </a:prstGeom>
+          <a:noFill/>
+        </p:spPr>
+        <p:txBody>
+          <a:bodyPr wrap="square">
+            <a:spAutoFit/>
+          </a:bodyPr>
+          <a:lstStyle/>
+          <a:p>
+            <a:pPr algn="ctr"/>
+            <a:r>
+              <a:rPr sz="1600" b="0">
+                <a:solidFill>
+                  <a:srgbClr val="2E1065"/>
+                </a:solidFill>
+                <a:latin typeface="Arial"/>
+              </a:rPr>
+              <a:t>Bước 3: Khi muốn tắt → Chọn Shut Down</a:t>
+            </a:r>
+          </a:p>
+        </p:txBody>
+      </p:sp>
     </p:spTree>
   </p:cSld>
   <p:clrMapOvr>
     <a:masterClrMapping/>
   </p:clrMapOvr>
   <p:transition spd="med">
-    <p:fade/>
+    <p:wipe/>
   </p:transition>
 </p:sld>
 </file>
@@ -5257,7 +6120,7 @@
         <p:spPr>
           <a:xfrm>
             <a:off x="457200" y="2286000"/>
-            <a:ext cx="11274552" cy="822960"/>
+            <a:ext cx="11274552" cy="640080"/>
           </a:xfrm>
           <a:prstGeom prst="rect">
             <a:avLst/>
@@ -5276,45 +6139,325 @@
               </a:spcAft>
             </a:pPr>
             <a:r>
-              <a:rPr sz="1700" b="0">
+              <a:rPr sz="1800" b="0">
                 <a:solidFill>
                   <a:srgbClr val="2E1065"/>
                 </a:solidFill>
                 <a:latin typeface="Arial"/>
               </a:rPr>
-              <a:t>● Chỉ vào từng bộ phận và gọi tên</a:t>
-            </a:r>
-          </a:p>
-          <a:p>
-            <a:pPr algn="l">
-              <a:spcAft>
-                <a:spcPts val="600"/>
-              </a:spcAft>
-            </a:pPr>
-            <a:r>
-              <a:rPr sz="1700" b="0">
+              <a:t>Thực hiện lần lượt các yêu cầu sau:</a:t>
+            </a:r>
+          </a:p>
+        </p:txBody>
+      </p:sp>
+      <p:sp>
+        <p:nvSpPr>
+          <p:cNvPr id="7" name="Rounded Rectangle 6"/>
+          <p:cNvSpPr/>
+          <p:nvPr/>
+        </p:nvSpPr>
+        <p:spPr>
+          <a:xfrm>
+            <a:off x="457200" y="3017520"/>
+            <a:ext cx="3605784" cy="1645919"/>
+          </a:xfrm>
+          <a:prstGeom prst="roundRect">
+            <a:avLst/>
+          </a:prstGeom>
+          <a:solidFill>
+            <a:srgbClr val="FFFFFF"/>
+          </a:solidFill>
+          <a:ln w="12700">
+            <a:solidFill>
+              <a:srgbClr val="7C3AED"/>
+            </a:solidFill>
+          </a:ln>
+        </p:spPr>
+        <p:style>
+          <a:lnRef idx="1">
+            <a:schemeClr val="accent1"/>
+          </a:lnRef>
+          <a:fillRef idx="3">
+            <a:schemeClr val="accent1"/>
+          </a:fillRef>
+          <a:effectRef idx="2">
+            <a:schemeClr val="accent1"/>
+          </a:effectRef>
+          <a:fontRef idx="minor">
+            <a:schemeClr val="lt1"/>
+          </a:fontRef>
+        </p:style>
+        <p:txBody>
+          <a:bodyPr rtlCol="0" anchor="ctr"/>
+          <a:lstStyle/>
+          <a:p>
+            <a:pPr algn="ctr"/>
+          </a:p>
+        </p:txBody>
+      </p:sp>
+      <p:pic>
+        <p:nvPicPr>
+          <p:cNvPr id="8" name="Picture 7" descr="activity.png"/>
+          <p:cNvPicPr>
+            <a:picLocks noChangeAspect="1"/>
+          </p:cNvPicPr>
+          <p:nvPr/>
+        </p:nvPicPr>
+        <p:blipFill>
+          <a:blip r:embed="rId2"/>
+          <a:stretch>
+            <a:fillRect/>
+          </a:stretch>
+        </p:blipFill>
+        <p:spPr>
+          <a:xfrm>
+            <a:off x="640080" y="3154679"/>
+            <a:ext cx="1280160" cy="1371599"/>
+          </a:xfrm>
+          <a:prstGeom prst="rect">
+            <a:avLst/>
+          </a:prstGeom>
+        </p:spPr>
+      </p:pic>
+      <p:sp>
+        <p:nvSpPr>
+          <p:cNvPr id="9" name="TextBox 8"/>
+          <p:cNvSpPr txBox="1"/>
+          <p:nvPr/>
+        </p:nvSpPr>
+        <p:spPr>
+          <a:xfrm>
+            <a:off x="2103120" y="3154679"/>
+            <a:ext cx="1868424" cy="1371600"/>
+          </a:xfrm>
+          <a:prstGeom prst="rect">
+            <a:avLst/>
+          </a:prstGeom>
+          <a:noFill/>
+        </p:spPr>
+        <p:txBody>
+          <a:bodyPr wrap="square">
+            <a:spAutoFit/>
+          </a:bodyPr>
+          <a:lstStyle/>
+          <a:p>
+            <a:pPr algn="l"/>
+            <a:r>
+              <a:rPr sz="1600" b="1">
                 <a:solidFill>
                   <a:srgbClr val="2E1065"/>
                 </a:solidFill>
                 <a:latin typeface="Arial"/>
               </a:rPr>
-              <a:t>● Thử nhấp chuột trái</a:t>
-            </a:r>
-          </a:p>
-          <a:p>
-            <a:pPr algn="l">
-              <a:spcAft>
-                <a:spcPts val="600"/>
-              </a:spcAft>
-            </a:pPr>
-            <a:r>
-              <a:rPr sz="1700" b="0">
+              <a:t>Chỉ vào từng bộ phận và gọi tên</a:t>
+            </a:r>
+          </a:p>
+        </p:txBody>
+      </p:sp>
+      <p:sp>
+        <p:nvSpPr>
+          <p:cNvPr id="10" name="Rounded Rectangle 9"/>
+          <p:cNvSpPr/>
+          <p:nvPr/>
+        </p:nvSpPr>
+        <p:spPr>
+          <a:xfrm>
+            <a:off x="4291584" y="3017520"/>
+            <a:ext cx="3605784" cy="1645919"/>
+          </a:xfrm>
+          <a:prstGeom prst="roundRect">
+            <a:avLst/>
+          </a:prstGeom>
+          <a:solidFill>
+            <a:srgbClr val="FFFFFF"/>
+          </a:solidFill>
+          <a:ln w="12700">
+            <a:solidFill>
+              <a:srgbClr val="7C3AED"/>
+            </a:solidFill>
+          </a:ln>
+        </p:spPr>
+        <p:style>
+          <a:lnRef idx="1">
+            <a:schemeClr val="accent1"/>
+          </a:lnRef>
+          <a:fillRef idx="3">
+            <a:schemeClr val="accent1"/>
+          </a:fillRef>
+          <a:effectRef idx="2">
+            <a:schemeClr val="accent1"/>
+          </a:effectRef>
+          <a:fontRef idx="minor">
+            <a:schemeClr val="lt1"/>
+          </a:fontRef>
+        </p:style>
+        <p:txBody>
+          <a:bodyPr rtlCol="0" anchor="ctr"/>
+          <a:lstStyle/>
+          <a:p>
+            <a:pPr algn="ctr"/>
+          </a:p>
+        </p:txBody>
+      </p:sp>
+      <p:pic>
+        <p:nvPicPr>
+          <p:cNvPr id="11" name="Picture 10" descr="cover.png"/>
+          <p:cNvPicPr>
+            <a:picLocks noChangeAspect="1"/>
+          </p:cNvPicPr>
+          <p:nvPr/>
+        </p:nvPicPr>
+        <p:blipFill>
+          <a:blip r:embed="rId3"/>
+          <a:stretch>
+            <a:fillRect/>
+          </a:stretch>
+        </p:blipFill>
+        <p:spPr>
+          <a:xfrm>
+            <a:off x="4474464" y="3154679"/>
+            <a:ext cx="1280160" cy="1371599"/>
+          </a:xfrm>
+          <a:prstGeom prst="rect">
+            <a:avLst/>
+          </a:prstGeom>
+        </p:spPr>
+      </p:pic>
+      <p:sp>
+        <p:nvSpPr>
+          <p:cNvPr id="12" name="TextBox 11"/>
+          <p:cNvSpPr txBox="1"/>
+          <p:nvPr/>
+        </p:nvSpPr>
+        <p:spPr>
+          <a:xfrm>
+            <a:off x="5937504" y="3154679"/>
+            <a:ext cx="1868424" cy="1371600"/>
+          </a:xfrm>
+          <a:prstGeom prst="rect">
+            <a:avLst/>
+          </a:prstGeom>
+          <a:noFill/>
+        </p:spPr>
+        <p:txBody>
+          <a:bodyPr wrap="square">
+            <a:spAutoFit/>
+          </a:bodyPr>
+          <a:lstStyle/>
+          <a:p>
+            <a:pPr algn="l"/>
+            <a:r>
+              <a:rPr sz="1600" b="1">
                 <a:solidFill>
                   <a:srgbClr val="2E1065"/>
                 </a:solidFill>
                 <a:latin typeface="Arial"/>
               </a:rPr>
-              <a:t>● Thử gõ tên mình bằng bàn phím</a:t>
+              <a:t>Thử nhấp chuột trái</a:t>
+            </a:r>
+          </a:p>
+        </p:txBody>
+      </p:sp>
+      <p:sp>
+        <p:nvSpPr>
+          <p:cNvPr id="13" name="Rounded Rectangle 12"/>
+          <p:cNvSpPr/>
+          <p:nvPr/>
+        </p:nvSpPr>
+        <p:spPr>
+          <a:xfrm>
+            <a:off x="8125968" y="3017520"/>
+            <a:ext cx="3605784" cy="1645919"/>
+          </a:xfrm>
+          <a:prstGeom prst="roundRect">
+            <a:avLst/>
+          </a:prstGeom>
+          <a:solidFill>
+            <a:srgbClr val="FFFFFF"/>
+          </a:solidFill>
+          <a:ln w="12700">
+            <a:solidFill>
+              <a:srgbClr val="7C3AED"/>
+            </a:solidFill>
+          </a:ln>
+        </p:spPr>
+        <p:style>
+          <a:lnRef idx="1">
+            <a:schemeClr val="accent1"/>
+          </a:lnRef>
+          <a:fillRef idx="3">
+            <a:schemeClr val="accent1"/>
+          </a:fillRef>
+          <a:effectRef idx="2">
+            <a:schemeClr val="accent1"/>
+          </a:effectRef>
+          <a:fontRef idx="minor">
+            <a:schemeClr val="lt1"/>
+          </a:fontRef>
+        </p:style>
+        <p:txBody>
+          <a:bodyPr rtlCol="0" anchor="ctr"/>
+          <a:lstStyle/>
+          <a:p>
+            <a:pPr algn="ctr"/>
+          </a:p>
+        </p:txBody>
+      </p:sp>
+      <p:pic>
+        <p:nvPicPr>
+          <p:cNvPr id="14" name="Picture 13" descr="practice.png"/>
+          <p:cNvPicPr>
+            <a:picLocks noChangeAspect="1"/>
+          </p:cNvPicPr>
+          <p:nvPr/>
+        </p:nvPicPr>
+        <p:blipFill>
+          <a:blip r:embed="rId4"/>
+          <a:stretch>
+            <a:fillRect/>
+          </a:stretch>
+        </p:blipFill>
+        <p:spPr>
+          <a:xfrm>
+            <a:off x="8308847" y="3154679"/>
+            <a:ext cx="1280160" cy="1371599"/>
+          </a:xfrm>
+          <a:prstGeom prst="rect">
+            <a:avLst/>
+          </a:prstGeom>
+        </p:spPr>
+      </p:pic>
+      <p:sp>
+        <p:nvSpPr>
+          <p:cNvPr id="15" name="TextBox 14"/>
+          <p:cNvSpPr txBox="1"/>
+          <p:nvPr/>
+        </p:nvSpPr>
+        <p:spPr>
+          <a:xfrm>
+            <a:off x="9771888" y="3154679"/>
+            <a:ext cx="1868424" cy="1371600"/>
+          </a:xfrm>
+          <a:prstGeom prst="rect">
+            <a:avLst/>
+          </a:prstGeom>
+          <a:noFill/>
+        </p:spPr>
+        <p:txBody>
+          <a:bodyPr wrap="square">
+            <a:spAutoFit/>
+          </a:bodyPr>
+          <a:lstStyle/>
+          <a:p>
+            <a:pPr algn="l"/>
+            <a:r>
+              <a:rPr sz="1600" b="1">
+                <a:solidFill>
+                  <a:srgbClr val="2E1065"/>
+                </a:solidFill>
+                <a:latin typeface="Arial"/>
+              </a:rPr>
+              <a:t>Thử gõ tên mình bằng bàn phím</a:t>
             </a:r>
           </a:p>
         </p:txBody>
@@ -5324,6 +6467,306 @@
   <p:clrMapOvr>
     <a:masterClrMapping/>
   </p:clrMapOvr>
+  <p:timing>
+    <p:tnLst>
+      <p:par>
+        <p:cTn id="1" dur="indefinite" restart="never" nodeType="tmRoot">
+          <p:childTnLst>
+            <p:seq concurrent="1" nextAc="seek">
+              <p:cTn id="2" dur="indefinite" nodeType="mainSeq">
+                <p:childTnLst>
+                  <p:par>
+                    <p:cTn id="3" fill="hold">
+                      <p:stCondLst>
+                        <p:cond delay="0"/>
+                      </p:stCondLst>
+                      <p:childTnLst>
+                        <p:par>
+                          <p:cTn id="4" presetID="1" presetClass="entr" presetSubtype="0" fill="hold">
+                            <p:stCondLst>
+                              <p:cond delay="0"/>
+                            </p:stCondLst>
+                            <p:childTnLst>
+                              <p:set>
+                                <p:cBhvr>
+                                  <p:cTn id="5" dur="1" fill="hold">
+                                    <p:stCondLst>
+                                      <p:cond delay="0"/>
+                                    </p:stCondLst>
+                                  </p:cTn>
+                                  <p:tgtEl>
+                                    <p:spTgt spid="7"/>
+                                  </p:tgtEl>
+                                  <p:attrNameLst>
+                                    <p:attrName>style.visibility</p:attrName>
+                                  </p:attrNameLst>
+                                </p:cBhvr>
+                                <p:to>
+                                  <p:strVal val="visible"/>
+                                </p:to>
+                              </p:set>
+                            </p:childTnLst>
+                          </p:cTn>
+                        </p:par>
+                        <p:par>
+                          <p:cTn id="6" presetID="1" presetClass="entr" presetSubtype="0" fill="hold">
+                            <p:stCondLst>
+                              <p:cond delay="0"/>
+                            </p:stCondLst>
+                            <p:childTnLst>
+                              <p:set>
+                                <p:cBhvr>
+                                  <p:cTn id="7" dur="1" fill="hold">
+                                    <p:stCondLst>
+                                      <p:cond delay="0"/>
+                                    </p:stCondLst>
+                                  </p:cTn>
+                                  <p:tgtEl>
+                                    <p:spTgt spid="8"/>
+                                  </p:tgtEl>
+                                  <p:attrNameLst>
+                                    <p:attrName>style.visibility</p:attrName>
+                                  </p:attrNameLst>
+                                </p:cBhvr>
+                                <p:to>
+                                  <p:strVal val="visible"/>
+                                </p:to>
+                              </p:set>
+                            </p:childTnLst>
+                          </p:cTn>
+                        </p:par>
+                        <p:par>
+                          <p:cTn id="8" presetID="1" presetClass="entr" presetSubtype="0" fill="hold">
+                            <p:stCondLst>
+                              <p:cond delay="0"/>
+                            </p:stCondLst>
+                            <p:childTnLst>
+                              <p:set>
+                                <p:cBhvr>
+                                  <p:cTn id="9" dur="1" fill="hold">
+                                    <p:stCondLst>
+                                      <p:cond delay="0"/>
+                                    </p:stCondLst>
+                                  </p:cTn>
+                                  <p:tgtEl>
+                                    <p:spTgt spid="9"/>
+                                  </p:tgtEl>
+                                  <p:attrNameLst>
+                                    <p:attrName>style.visibility</p:attrName>
+                                  </p:attrNameLst>
+                                </p:cBhvr>
+                                <p:to>
+                                  <p:strVal val="visible"/>
+                                </p:to>
+                              </p:set>
+                            </p:childTnLst>
+                          </p:cTn>
+                        </p:par>
+                      </p:childTnLst>
+                    </p:cTn>
+                  </p:par>
+                  <p:par>
+                    <p:cTn id="10" fill="hold">
+                      <p:stCondLst>
+                        <p:cond delay="0"/>
+                      </p:stCondLst>
+                      <p:childTnLst>
+                        <p:par>
+                          <p:cTn id="11" presetID="1" presetClass="entr" presetSubtype="0" fill="hold">
+                            <p:stCondLst>
+                              <p:cond delay="0"/>
+                            </p:stCondLst>
+                            <p:childTnLst>
+                              <p:set>
+                                <p:cBhvr>
+                                  <p:cTn id="12" dur="1" fill="hold">
+                                    <p:stCondLst>
+                                      <p:cond delay="0"/>
+                                    </p:stCondLst>
+                                  </p:cTn>
+                                  <p:tgtEl>
+                                    <p:spTgt spid="10"/>
+                                  </p:tgtEl>
+                                  <p:attrNameLst>
+                                    <p:attrName>style.visibility</p:attrName>
+                                  </p:attrNameLst>
+                                </p:cBhvr>
+                                <p:to>
+                                  <p:strVal val="visible"/>
+                                </p:to>
+                              </p:set>
+                            </p:childTnLst>
+                          </p:cTn>
+                        </p:par>
+                        <p:par>
+                          <p:cTn id="13" presetID="1" presetClass="entr" presetSubtype="0" fill="hold">
+                            <p:stCondLst>
+                              <p:cond delay="0"/>
+                            </p:stCondLst>
+                            <p:childTnLst>
+                              <p:set>
+                                <p:cBhvr>
+                                  <p:cTn id="14" dur="1" fill="hold">
+                                    <p:stCondLst>
+                                      <p:cond delay="0"/>
+                                    </p:stCondLst>
+                                  </p:cTn>
+                                  <p:tgtEl>
+                                    <p:spTgt spid="11"/>
+                                  </p:tgtEl>
+                                  <p:attrNameLst>
+                                    <p:attrName>style.visibility</p:attrName>
+                                  </p:attrNameLst>
+                                </p:cBhvr>
+                                <p:to>
+                                  <p:strVal val="visible"/>
+                                </p:to>
+                              </p:set>
+                            </p:childTnLst>
+                          </p:cTn>
+                        </p:par>
+                        <p:par>
+                          <p:cTn id="15" presetID="1" presetClass="entr" presetSubtype="0" fill="hold">
+                            <p:stCondLst>
+                              <p:cond delay="0"/>
+                            </p:stCondLst>
+                            <p:childTnLst>
+                              <p:set>
+                                <p:cBhvr>
+                                  <p:cTn id="16" dur="1" fill="hold">
+                                    <p:stCondLst>
+                                      <p:cond delay="0"/>
+                                    </p:stCondLst>
+                                  </p:cTn>
+                                  <p:tgtEl>
+                                    <p:spTgt spid="12"/>
+                                  </p:tgtEl>
+                                  <p:attrNameLst>
+                                    <p:attrName>style.visibility</p:attrName>
+                                  </p:attrNameLst>
+                                </p:cBhvr>
+                                <p:to>
+                                  <p:strVal val="visible"/>
+                                </p:to>
+                              </p:set>
+                            </p:childTnLst>
+                          </p:cTn>
+                        </p:par>
+                      </p:childTnLst>
+                    </p:cTn>
+                  </p:par>
+                  <p:par>
+                    <p:cTn id="17" fill="hold">
+                      <p:stCondLst>
+                        <p:cond delay="0"/>
+                      </p:stCondLst>
+                      <p:childTnLst>
+                        <p:par>
+                          <p:cTn id="18" presetID="1" presetClass="entr" presetSubtype="0" fill="hold">
+                            <p:stCondLst>
+                              <p:cond delay="0"/>
+                            </p:stCondLst>
+                            <p:childTnLst>
+                              <p:set>
+                                <p:cBhvr>
+                                  <p:cTn id="19" dur="1" fill="hold">
+                                    <p:stCondLst>
+                                      <p:cond delay="0"/>
+                                    </p:stCondLst>
+                                  </p:cTn>
+                                  <p:tgtEl>
+                                    <p:spTgt spid="13"/>
+                                  </p:tgtEl>
+                                  <p:attrNameLst>
+                                    <p:attrName>style.visibility</p:attrName>
+                                  </p:attrNameLst>
+                                </p:cBhvr>
+                                <p:to>
+                                  <p:strVal val="visible"/>
+                                </p:to>
+                              </p:set>
+                            </p:childTnLst>
+                          </p:cTn>
+                        </p:par>
+                        <p:par>
+                          <p:cTn id="20" presetID="1" presetClass="entr" presetSubtype="0" fill="hold">
+                            <p:stCondLst>
+                              <p:cond delay="0"/>
+                            </p:stCondLst>
+                            <p:childTnLst>
+                              <p:set>
+                                <p:cBhvr>
+                                  <p:cTn id="21" dur="1" fill="hold">
+                                    <p:stCondLst>
+                                      <p:cond delay="0"/>
+                                    </p:stCondLst>
+                                  </p:cTn>
+                                  <p:tgtEl>
+                                    <p:spTgt spid="14"/>
+                                  </p:tgtEl>
+                                  <p:attrNameLst>
+                                    <p:attrName>style.visibility</p:attrName>
+                                  </p:attrNameLst>
+                                </p:cBhvr>
+                                <p:to>
+                                  <p:strVal val="visible"/>
+                                </p:to>
+                              </p:set>
+                            </p:childTnLst>
+                          </p:cTn>
+                        </p:par>
+                        <p:par>
+                          <p:cTn id="22" presetID="1" presetClass="entr" presetSubtype="0" fill="hold">
+                            <p:stCondLst>
+                              <p:cond delay="0"/>
+                            </p:stCondLst>
+                            <p:childTnLst>
+                              <p:set>
+                                <p:cBhvr>
+                                  <p:cTn id="23" dur="1" fill="hold">
+                                    <p:stCondLst>
+                                      <p:cond delay="0"/>
+                                    </p:stCondLst>
+                                  </p:cTn>
+                                  <p:tgtEl>
+                                    <p:spTgt spid="15"/>
+                                  </p:tgtEl>
+                                  <p:attrNameLst>
+                                    <p:attrName>style.visibility</p:attrName>
+                                  </p:attrNameLst>
+                                </p:cBhvr>
+                                <p:to>
+                                  <p:strVal val="visible"/>
+                                </p:to>
+                              </p:set>
+                            </p:childTnLst>
+                          </p:cTn>
+                        </p:par>
+                      </p:childTnLst>
+                    </p:cTn>
+                  </p:par>
+                </p:childTnLst>
+              </p:cTn>
+              <p:prevCondLst>
+                <p:cond evt="onPrev" delay="0">
+                  <p:tgtEl>
+                    <p:sldTgt/>
+                  </p:tgtEl>
+                </p:cond>
+              </p:prevCondLst>
+              <p:nextCondLst>
+                <p:cond evt="onNext" delay="0">
+                  <p:tgtEl>
+                    <p:sldTgt/>
+                  </p:tgtEl>
+                </p:cond>
+              </p:nextCondLst>
+            </p:seq>
+          </p:childTnLst>
+        </p:cTn>
+      </p:par>
+    </p:tnLst>
+  </p:timing>
   <p:transition spd="med">
     <p:wipe/>
   </p:transition>
@@ -5456,7 +6899,7 @@
                 </a:solidFill>
                 <a:latin typeface="Arial"/>
               </a:rPr>
-              <a:t>  LỚP 1 • LUYỆN TẬP</a:t>
+              <a:t>  LỚP 1 • THỬ THÁCH</a:t>
             </a:r>
           </a:p>
         </p:txBody>
@@ -5498,14 +6941,100 @@
       </p:sp>
       <p:sp>
         <p:nvSpPr>
-          <p:cNvPr id="6" name="TextBox 5"/>
+          <p:cNvPr id="6" name="Rounded Rectangle 5"/>
+          <p:cNvSpPr/>
+          <p:nvPr/>
+        </p:nvSpPr>
+        <p:spPr>
+          <a:xfrm>
+            <a:off x="365760" y="2286000"/>
+            <a:ext cx="6400800" cy="3383279"/>
+          </a:xfrm>
+          <a:prstGeom prst="roundRect">
+            <a:avLst/>
+          </a:prstGeom>
+          <a:solidFill>
+            <a:srgbClr val="FFFFFF"/>
+          </a:solidFill>
+          <a:ln>
+            <a:noFill/>
+          </a:ln>
+        </p:spPr>
+        <p:style>
+          <a:lnRef idx="1">
+            <a:schemeClr val="accent1"/>
+          </a:lnRef>
+          <a:fillRef idx="3">
+            <a:schemeClr val="accent1"/>
+          </a:fillRef>
+          <a:effectRef idx="2">
+            <a:schemeClr val="accent1"/>
+          </a:effectRef>
+          <a:fontRef idx="minor">
+            <a:schemeClr val="lt1"/>
+          </a:fontRef>
+        </p:style>
+        <p:txBody>
+          <a:bodyPr rtlCol="0" anchor="ctr"/>
+          <a:lstStyle/>
+          <a:p>
+            <a:pPr algn="ctr"/>
+          </a:p>
+        </p:txBody>
+      </p:sp>
+      <p:sp>
+        <p:nvSpPr>
+          <p:cNvPr id="7" name="Rectangle 6"/>
+          <p:cNvSpPr/>
+          <p:nvPr/>
+        </p:nvSpPr>
+        <p:spPr>
+          <a:xfrm>
+            <a:off x="365760" y="2286000"/>
+            <a:ext cx="109728" cy="3383279"/>
+          </a:xfrm>
+          <a:prstGeom prst="rect">
+            <a:avLst/>
+          </a:prstGeom>
+          <a:solidFill>
+            <a:srgbClr val="7C3AED"/>
+          </a:solidFill>
+          <a:ln>
+            <a:noFill/>
+          </a:ln>
+        </p:spPr>
+        <p:style>
+          <a:lnRef idx="1">
+            <a:schemeClr val="accent1"/>
+          </a:lnRef>
+          <a:fillRef idx="3">
+            <a:schemeClr val="accent1"/>
+          </a:fillRef>
+          <a:effectRef idx="2">
+            <a:schemeClr val="accent1"/>
+          </a:effectRef>
+          <a:fontRef idx="minor">
+            <a:schemeClr val="lt1"/>
+          </a:fontRef>
+        </p:style>
+        <p:txBody>
+          <a:bodyPr rtlCol="0" anchor="ctr"/>
+          <a:lstStyle/>
+          <a:p>
+            <a:pPr algn="ctr"/>
+          </a:p>
+        </p:txBody>
+      </p:sp>
+      <p:sp>
+        <p:nvSpPr>
+          <p:cNvPr id="8" name="TextBox 7"/>
           <p:cNvSpPr txBox="1"/>
           <p:nvPr/>
         </p:nvSpPr>
         <p:spPr>
           <a:xfrm>
-            <a:off x="457200" y="2286000"/>
-            <a:ext cx="11274552" cy="822960"/>
+            <a:off x="731520" y="2468880"/>
+            <a:ext cx="5852160" cy="3017520"/>
           </a:xfrm>
           <a:prstGeom prst="rect">
             <a:avLst/>
@@ -5524,344 +7053,48 @@
               </a:spcAft>
             </a:pPr>
             <a:r>
-              <a:rPr sz="1700" b="0">
+              <a:rPr sz="2000" b="0">
                 <a:solidFill>
                   <a:srgbClr val="2E1065"/>
                 </a:solidFill>
                 <a:latin typeface="Arial"/>
               </a:rPr>
-              <a:t>Nối tên với hình ảnh đúng:</a:t>
-            </a:r>
-          </a:p>
-        </p:txBody>
-      </p:sp>
-      <p:sp>
-        <p:nvSpPr>
-          <p:cNvPr id="7" name="Rounded Rectangle 6"/>
-          <p:cNvSpPr/>
-          <p:nvPr/>
-        </p:nvSpPr>
-        <p:spPr>
-          <a:xfrm>
-            <a:off x="457200" y="3200400"/>
-            <a:ext cx="5545836" cy="548639"/>
-          </a:xfrm>
-          <a:prstGeom prst="roundRect">
-            <a:avLst/>
-          </a:prstGeom>
-          <a:solidFill>
-            <a:srgbClr val="FFFFFF"/>
-          </a:solidFill>
-          <a:ln w="12700">
-            <a:solidFill>
-              <a:srgbClr val="7C3AED"/>
-            </a:solidFill>
-          </a:ln>
-        </p:spPr>
-        <p:style>
-          <a:lnRef idx="1">
-            <a:schemeClr val="accent1"/>
-          </a:lnRef>
-          <a:fillRef idx="3">
-            <a:schemeClr val="accent1"/>
-          </a:fillRef>
-          <a:effectRef idx="2">
-            <a:schemeClr val="accent1"/>
-          </a:effectRef>
-          <a:fontRef idx="minor">
-            <a:schemeClr val="lt1"/>
-          </a:fontRef>
-        </p:style>
-        <p:txBody>
-          <a:bodyPr rtlCol="0" anchor="ctr"/>
-          <a:lstStyle/>
-          <a:p>
-            <a:pPr algn="ctr"/>
-          </a:p>
-        </p:txBody>
-      </p:sp>
-      <p:sp>
-        <p:nvSpPr>
-          <p:cNvPr id="8" name="TextBox 7"/>
-          <p:cNvSpPr txBox="1"/>
-          <p:nvPr/>
-        </p:nvSpPr>
-        <p:spPr>
-          <a:xfrm>
-            <a:off x="685800" y="3291840"/>
-            <a:ext cx="5180076" cy="365760"/>
-          </a:xfrm>
-          <a:prstGeom prst="rect">
-            <a:avLst/>
-          </a:prstGeom>
-          <a:noFill/>
-        </p:spPr>
-        <p:txBody>
-          <a:bodyPr wrap="square">
-            <a:spAutoFit/>
-          </a:bodyPr>
-          <a:lstStyle/>
-          <a:p>
-            <a:pPr algn="l"/>
-            <a:r>
-              <a:rPr sz="1500" b="0">
-                <a:solidFill>
-                  <a:srgbClr val="2E1065"/>
-                </a:solidFill>
-                <a:latin typeface="Arial"/>
-              </a:rPr>
-              <a:t>Màn hình ↔ ?</a:t>
-            </a:r>
-          </a:p>
-        </p:txBody>
-      </p:sp>
-      <p:sp>
-        <p:nvSpPr>
-          <p:cNvPr id="9" name="Rounded Rectangle 8"/>
-          <p:cNvSpPr/>
-          <p:nvPr/>
-        </p:nvSpPr>
-        <p:spPr>
-          <a:xfrm>
-            <a:off x="6185916" y="3200400"/>
-            <a:ext cx="5545836" cy="548639"/>
-          </a:xfrm>
-          <a:prstGeom prst="roundRect">
-            <a:avLst/>
-          </a:prstGeom>
-          <a:solidFill>
-            <a:srgbClr val="FFFFFF"/>
-          </a:solidFill>
-          <a:ln w="12700">
-            <a:solidFill>
-              <a:srgbClr val="7C3AED"/>
-            </a:solidFill>
-          </a:ln>
-        </p:spPr>
-        <p:style>
-          <a:lnRef idx="1">
-            <a:schemeClr val="accent1"/>
-          </a:lnRef>
-          <a:fillRef idx="3">
-            <a:schemeClr val="accent1"/>
-          </a:fillRef>
-          <a:effectRef idx="2">
-            <a:schemeClr val="accent1"/>
-          </a:effectRef>
-          <a:fontRef idx="minor">
-            <a:schemeClr val="lt1"/>
-          </a:fontRef>
-        </p:style>
-        <p:txBody>
-          <a:bodyPr rtlCol="0" anchor="ctr"/>
-          <a:lstStyle/>
-          <a:p>
-            <a:pPr algn="ctr"/>
-          </a:p>
-        </p:txBody>
-      </p:sp>
-      <p:sp>
-        <p:nvSpPr>
-          <p:cNvPr id="10" name="TextBox 9"/>
-          <p:cNvSpPr txBox="1"/>
-          <p:nvPr/>
-        </p:nvSpPr>
-        <p:spPr>
-          <a:xfrm>
-            <a:off x="6414516" y="3291840"/>
-            <a:ext cx="5180076" cy="365760"/>
-          </a:xfrm>
-          <a:prstGeom prst="rect">
-            <a:avLst/>
-          </a:prstGeom>
-          <a:noFill/>
-        </p:spPr>
-        <p:txBody>
-          <a:bodyPr wrap="square">
-            <a:spAutoFit/>
-          </a:bodyPr>
-          <a:lstStyle/>
-          <a:p>
-            <a:pPr algn="l"/>
-            <a:r>
-              <a:rPr sz="1500" b="0">
-                <a:solidFill>
-                  <a:srgbClr val="2E1065"/>
-                </a:solidFill>
-                <a:latin typeface="Arial"/>
-              </a:rPr>
-              <a:t>Bàn phím ↔ ?</a:t>
-            </a:r>
-          </a:p>
-        </p:txBody>
-      </p:sp>
-      <p:sp>
-        <p:nvSpPr>
-          <p:cNvPr id="11" name="Rounded Rectangle 10"/>
-          <p:cNvSpPr/>
-          <p:nvPr/>
-        </p:nvSpPr>
-        <p:spPr>
-          <a:xfrm>
-            <a:off x="457200" y="3886200"/>
-            <a:ext cx="5545836" cy="548639"/>
-          </a:xfrm>
-          <a:prstGeom prst="roundRect">
-            <a:avLst/>
-          </a:prstGeom>
-          <a:solidFill>
-            <a:srgbClr val="FFFFFF"/>
-          </a:solidFill>
-          <a:ln w="12700">
-            <a:solidFill>
-              <a:srgbClr val="7C3AED"/>
-            </a:solidFill>
-          </a:ln>
-        </p:spPr>
-        <p:style>
-          <a:lnRef idx="1">
-            <a:schemeClr val="accent1"/>
-          </a:lnRef>
-          <a:fillRef idx="3">
-            <a:schemeClr val="accent1"/>
-          </a:fillRef>
-          <a:effectRef idx="2">
-            <a:schemeClr val="accent1"/>
-          </a:effectRef>
-          <a:fontRef idx="minor">
-            <a:schemeClr val="lt1"/>
-          </a:fontRef>
-        </p:style>
-        <p:txBody>
-          <a:bodyPr rtlCol="0" anchor="ctr"/>
-          <a:lstStyle/>
-          <a:p>
-            <a:pPr algn="ctr"/>
-          </a:p>
-        </p:txBody>
-      </p:sp>
-      <p:sp>
-        <p:nvSpPr>
-          <p:cNvPr id="12" name="TextBox 11"/>
-          <p:cNvSpPr txBox="1"/>
-          <p:nvPr/>
-        </p:nvSpPr>
-        <p:spPr>
-          <a:xfrm>
-            <a:off x="685800" y="3977639"/>
-            <a:ext cx="5180076" cy="365760"/>
-          </a:xfrm>
-          <a:prstGeom prst="rect">
-            <a:avLst/>
-          </a:prstGeom>
-          <a:noFill/>
-        </p:spPr>
-        <p:txBody>
-          <a:bodyPr wrap="square">
-            <a:spAutoFit/>
-          </a:bodyPr>
-          <a:lstStyle/>
-          <a:p>
-            <a:pPr algn="l"/>
-            <a:r>
-              <a:rPr sz="1500" b="0">
-                <a:solidFill>
-                  <a:srgbClr val="2E1065"/>
-                </a:solidFill>
-                <a:latin typeface="Arial"/>
-              </a:rPr>
-              <a:t>Chuột ↔ ?</a:t>
-            </a:r>
-          </a:p>
-        </p:txBody>
-      </p:sp>
-      <p:sp>
-        <p:nvSpPr>
-          <p:cNvPr id="13" name="Rounded Rectangle 12"/>
-          <p:cNvSpPr/>
-          <p:nvPr/>
-        </p:nvSpPr>
-        <p:spPr>
-          <a:xfrm>
-            <a:off x="6185916" y="3886200"/>
-            <a:ext cx="5545836" cy="548639"/>
-          </a:xfrm>
-          <a:prstGeom prst="roundRect">
-            <a:avLst/>
-          </a:prstGeom>
-          <a:solidFill>
-            <a:srgbClr val="FFFFFF"/>
-          </a:solidFill>
-          <a:ln w="12700">
-            <a:solidFill>
-              <a:srgbClr val="7C3AED"/>
-            </a:solidFill>
-          </a:ln>
-        </p:spPr>
-        <p:style>
-          <a:lnRef idx="1">
-            <a:schemeClr val="accent1"/>
-          </a:lnRef>
-          <a:fillRef idx="3">
-            <a:schemeClr val="accent1"/>
-          </a:fillRef>
-          <a:effectRef idx="2">
-            <a:schemeClr val="accent1"/>
-          </a:effectRef>
-          <a:fontRef idx="minor">
-            <a:schemeClr val="lt1"/>
-          </a:fontRef>
-        </p:style>
-        <p:txBody>
-          <a:bodyPr rtlCol="0" anchor="ctr"/>
-          <a:lstStyle/>
-          <a:p>
-            <a:pPr algn="ctr"/>
-          </a:p>
-        </p:txBody>
-      </p:sp>
-      <p:sp>
-        <p:nvSpPr>
-          <p:cNvPr id="14" name="TextBox 13"/>
-          <p:cNvSpPr txBox="1"/>
-          <p:nvPr/>
-        </p:nvSpPr>
-        <p:spPr>
-          <a:xfrm>
-            <a:off x="6414516" y="3977639"/>
-            <a:ext cx="5180076" cy="365760"/>
-          </a:xfrm>
-          <a:prstGeom prst="rect">
-            <a:avLst/>
-          </a:prstGeom>
-          <a:noFill/>
-        </p:spPr>
-        <p:txBody>
-          <a:bodyPr wrap="square">
-            <a:spAutoFit/>
-          </a:bodyPr>
-          <a:lstStyle/>
-          <a:p>
-            <a:pPr algn="l"/>
-            <a:r>
-              <a:rPr sz="1500" b="0">
-                <a:solidFill>
-                  <a:srgbClr val="2E1065"/>
-                </a:solidFill>
-                <a:latin typeface="Arial"/>
-              </a:rPr>
-              <a:t>Thân máy ↔ ?</a:t>
-            </a:r>
-          </a:p>
-        </p:txBody>
-      </p:sp>
+              <a:t>Nối tên bộ phận với công dụng đúng:</a:t>
+            </a:r>
+          </a:p>
+        </p:txBody>
+      </p:sp>
+      <p:pic>
+        <p:nvPicPr>
+          <p:cNvPr id="9" name="Picture 8" descr="activity.png"/>
+          <p:cNvPicPr>
+            <a:picLocks noChangeAspect="1"/>
+          </p:cNvPicPr>
+          <p:nvPr/>
+        </p:nvPicPr>
+        <p:blipFill>
+          <a:blip r:embed="rId2"/>
+          <a:stretch>
+            <a:fillRect/>
+          </a:stretch>
+        </p:blipFill>
+        <p:spPr>
+          <a:xfrm>
+            <a:off x="7132320" y="2377440"/>
+            <a:ext cx="4572000" cy="3200399"/>
+          </a:xfrm>
+          <a:prstGeom prst="rect">
+            <a:avLst/>
+          </a:prstGeom>
+        </p:spPr>
+      </p:pic>
     </p:spTree>
   </p:cSld>
   <p:clrMapOvr>
     <a:masterClrMapping/>
   </p:clrMapOvr>
   <p:transition spd="med">
-    <p:wipe/>
+    <p:cover/>
   </p:transition>
 </p:sld>
 </file>
@@ -6177,8 +7410,8 @@
         </p:nvSpPr>
         <p:spPr>
           <a:xfrm>
-            <a:off x="1371600" y="2377440"/>
-            <a:ext cx="9445752" cy="457200"/>
+            <a:off x="1371600" y="2423160"/>
+            <a:ext cx="9445752" cy="365760"/>
           </a:xfrm>
           <a:prstGeom prst="rect">
             <a:avLst/>
@@ -6199,7 +7432,7 @@
                 </a:solidFill>
                 <a:latin typeface="Arial"/>
               </a:rPr>
-              <a:t>Máy tính có nhiều loại</a:t>
+              <a:t>Máy tính có nhiều loại khác nhau</a:t>
             </a:r>
           </a:p>
         </p:txBody>
@@ -6212,8 +7445,8 @@
         </p:nvSpPr>
         <p:spPr>
           <a:xfrm>
-            <a:off x="914400" y="3200400"/>
-            <a:ext cx="73152" cy="640080"/>
+            <a:off x="914400" y="3291840"/>
+            <a:ext cx="73152" cy="640079"/>
           </a:xfrm>
           <a:prstGeom prst="rect">
             <a:avLst/>
@@ -6255,8 +7488,8 @@
         </p:nvSpPr>
         <p:spPr>
           <a:xfrm>
-            <a:off x="1097280" y="3200400"/>
-            <a:ext cx="9994392" cy="640080"/>
+            <a:off x="1097280" y="3291840"/>
+            <a:ext cx="9994392" cy="640079"/>
           </a:xfrm>
           <a:prstGeom prst="roundRect">
             <a:avLst/>
@@ -6298,8 +7531,8 @@
         </p:nvSpPr>
         <p:spPr>
           <a:xfrm>
-            <a:off x="1371600" y="3291840"/>
-            <a:ext cx="9445752" cy="457200"/>
+            <a:off x="1371600" y="3429000"/>
+            <a:ext cx="9445752" cy="365760"/>
           </a:xfrm>
           <a:prstGeom prst="rect">
             <a:avLst/>
@@ -6333,7 +7566,7 @@
         </p:nvSpPr>
         <p:spPr>
           <a:xfrm>
-            <a:off x="914400" y="4114800"/>
+            <a:off x="914400" y="4297680"/>
             <a:ext cx="73152" cy="640080"/>
           </a:xfrm>
           <a:prstGeom prst="rect">
@@ -6376,7 +7609,7 @@
         </p:nvSpPr>
         <p:spPr>
           <a:xfrm>
-            <a:off x="1097280" y="4114800"/>
+            <a:off x="1097280" y="4297680"/>
             <a:ext cx="9994392" cy="640080"/>
           </a:xfrm>
           <a:prstGeom prst="roundRect">
@@ -6419,8 +7652,8 @@
         </p:nvSpPr>
         <p:spPr>
           <a:xfrm>
-            <a:off x="1371600" y="4206240"/>
-            <a:ext cx="9445752" cy="457200"/>
+            <a:off x="1371600" y="4434840"/>
+            <a:ext cx="9445752" cy="365760"/>
           </a:xfrm>
           <a:prstGeom prst="rect">
             <a:avLst/>
@@ -6441,7 +7674,7 @@
                 </a:solidFill>
                 <a:latin typeface="Arial"/>
               </a:rPr>
-              <a:t>Bật/tắt máy đúng cách</a:t>
+              <a:t>Bật/Tắt máy tính đúng quy trình</a:t>
             </a:r>
           </a:p>
         </p:txBody>
@@ -6518,7 +7751,7 @@
         </p:nvSpPr>
         <p:spPr>
           <a:xfrm>
-            <a:off x="914400" y="1508760"/>
+            <a:off x="914400" y="1783080"/>
             <a:ext cx="10360152" cy="1097280"/>
           </a:xfrm>
           <a:prstGeom prst="rect">
@@ -6553,8 +7786,8 @@
         </p:nvSpPr>
         <p:spPr>
           <a:xfrm>
-            <a:off x="2436876" y="3063240"/>
-            <a:ext cx="7315200" cy="2285999"/>
+            <a:off x="2436876" y="3337560"/>
+            <a:ext cx="7315200" cy="1828800"/>
           </a:xfrm>
           <a:prstGeom prst="roundRect">
             <a:avLst/>
@@ -6596,8 +7829,8 @@
         </p:nvSpPr>
         <p:spPr>
           <a:xfrm>
-            <a:off x="2894076" y="3337560"/>
-            <a:ext cx="6400800" cy="1737360"/>
+            <a:off x="2894076" y="3611879"/>
+            <a:ext cx="6400800" cy="1280160"/>
           </a:xfrm>
           <a:prstGeom prst="rect">
             <a:avLst/>
@@ -6616,7 +7849,7 @@
               </a:spcAft>
             </a:pPr>
             <a:r>
-              <a:rPr sz="1800" b="0">
+              <a:rPr sz="2000" b="0">
                 <a:solidFill>
                   <a:srgbClr val="2E1065"/>
                 </a:solidFill>
@@ -6632,7 +7865,7 @@
               </a:spcAft>
             </a:pPr>
             <a:r>
-              <a:rPr sz="1800" b="0">
+              <a:rPr sz="2000" b="0">
                 <a:solidFill>
                   <a:srgbClr val="2E1065"/>
                 </a:solidFill>

</xml_diff>